<commit_message>
feat:Updated my final notebook and my presentation slides with missing information
</commit_message>
<xml_diff>
--- a/Presentation/Seasonal_flu_prediction_analysis_presenatation.pptx
+++ b/Presentation/Seasonal_flu_prediction_analysis_presenatation.pptx
@@ -5,24 +5,26 @@
     <p:sldMasterId id="2147483648" r:id="rId1"/>
   </p:sldMasterIdLst>
   <p:notesMasterIdLst>
-    <p:notesMasterId r:id="rId17"/>
+    <p:notesMasterId r:id="rId19"/>
   </p:notesMasterIdLst>
   <p:sldIdLst>
     <p:sldId id="256" r:id="rId2"/>
-    <p:sldId id="257" r:id="rId3"/>
-    <p:sldId id="258" r:id="rId4"/>
-    <p:sldId id="259" r:id="rId5"/>
-    <p:sldId id="260" r:id="rId6"/>
-    <p:sldId id="261" r:id="rId7"/>
-    <p:sldId id="262" r:id="rId8"/>
-    <p:sldId id="263" r:id="rId9"/>
-    <p:sldId id="264" r:id="rId10"/>
-    <p:sldId id="265" r:id="rId11"/>
-    <p:sldId id="266" r:id="rId12"/>
-    <p:sldId id="267" r:id="rId13"/>
-    <p:sldId id="268" r:id="rId14"/>
-    <p:sldId id="269" r:id="rId15"/>
-    <p:sldId id="270" r:id="rId16"/>
+    <p:sldId id="271" r:id="rId3"/>
+    <p:sldId id="257" r:id="rId4"/>
+    <p:sldId id="258" r:id="rId5"/>
+    <p:sldId id="259" r:id="rId6"/>
+    <p:sldId id="260" r:id="rId7"/>
+    <p:sldId id="261" r:id="rId8"/>
+    <p:sldId id="262" r:id="rId9"/>
+    <p:sldId id="263" r:id="rId10"/>
+    <p:sldId id="273" r:id="rId11"/>
+    <p:sldId id="264" r:id="rId12"/>
+    <p:sldId id="265" r:id="rId13"/>
+    <p:sldId id="266" r:id="rId14"/>
+    <p:sldId id="267" r:id="rId15"/>
+    <p:sldId id="268" r:id="rId16"/>
+    <p:sldId id="269" r:id="rId17"/>
+    <p:sldId id="270" r:id="rId18"/>
   </p:sldIdLst>
   <p:sldSz cx="9144000" cy="5143500" type="screen16x9"/>
   <p:notesSz cx="5143500" cy="9144000"/>
@@ -398,11 +400,71 @@
           <a:bodyPr/>
           <a:lstStyle/>
           <a:p>
+            <a:pPr marL="0" marR="0" lvl="0" indent="0" algn="l" defTabSz="914400" rtl="0" eaLnBrk="1" fontAlgn="auto" latinLnBrk="0" hangingPunct="1">
+              <a:lnSpc>
+                <a:spcPct val="100000"/>
+              </a:lnSpc>
+              <a:spcBef>
+                <a:spcPts val="0"/>
+              </a:spcBef>
+              <a:spcAft>
+                <a:spcPts val="0"/>
+              </a:spcAft>
+              <a:buClrTx/>
+              <a:buSzTx/>
+              <a:buFontTx/>
+              <a:buNone/>
+              <a:tabLst/>
+              <a:defRPr/>
+            </a:pPr>
             <a:fld id="{F7021451-1387-4CA6-816F-3879F97B5CBC}" type="slidenum">
-              <a:rPr lang="en-US"/>
+              <a:rPr kumimoji="0" lang="en-US" sz="1800" b="0" i="0" u="none" strike="noStrike" kern="1200" cap="none" spc="0" normalizeH="0" baseline="0" noProof="0">
+                <a:ln>
+                  <a:noFill/>
+                </a:ln>
+                <a:solidFill>
+                  <a:prstClr val="black"/>
+                </a:solidFill>
+                <a:effectLst/>
+                <a:uLnTx/>
+                <a:uFillTx/>
+                <a:latin typeface="Aptos" panose="02110004020202020204"/>
+                <a:ea typeface="+mn-ea"/>
+                <a:cs typeface="+mn-cs"/>
+              </a:rPr>
+              <a:pPr marL="0" marR="0" lvl="0" indent="0" algn="l" defTabSz="914400" rtl="0" eaLnBrk="1" fontAlgn="auto" latinLnBrk="0" hangingPunct="1">
+                <a:lnSpc>
+                  <a:spcPct val="100000"/>
+                </a:lnSpc>
+                <a:spcBef>
+                  <a:spcPts val="0"/>
+                </a:spcBef>
+                <a:spcAft>
+                  <a:spcPts val="0"/>
+                </a:spcAft>
+                <a:buClrTx/>
+                <a:buSzTx/>
+                <a:buFontTx/>
+                <a:buNone/>
+                <a:tabLst/>
+                <a:defRPr/>
+              </a:pPr>
               <a:t>10</a:t>
             </a:fld>
-            <a:endParaRPr lang="en-US"/>
+            <a:endParaRPr kumimoji="0" lang="en-US" sz="1800" b="0" i="0" u="none" strike="noStrike" kern="1200" cap="none" spc="0" normalizeH="0" baseline="0" noProof="0">
+              <a:ln>
+                <a:noFill/>
+              </a:ln>
+              <a:solidFill>
+                <a:prstClr val="black"/>
+              </a:solidFill>
+              <a:effectLst/>
+              <a:uLnTx/>
+              <a:uFillTx/>
+              <a:latin typeface="Aptos" panose="02110004020202020204"/>
+              <a:ea typeface="+mn-ea"/>
+              <a:cs typeface="+mn-cs"/>
+            </a:endParaRPr>
           </a:p>
         </p:txBody>
       </p:sp>
@@ -760,6 +822,174 @@
   <p:cSld>
     <p:spTree>
       <p:nvGrpSpPr>
+        <p:cNvPr id="1" name=""/>
+        <p:cNvGrpSpPr/>
+        <p:nvPr/>
+      </p:nvGrpSpPr>
+      <p:grpSpPr>
+        <a:xfrm>
+          <a:off x="0" y="0"/>
+          <a:ext cx="0" cy="0"/>
+          <a:chOff x="0" y="0"/>
+          <a:chExt cx="0" cy="0"/>
+        </a:xfrm>
+      </p:grpSpPr>
+      <p:sp>
+        <p:nvSpPr>
+          <p:cNvPr id="2" name="Slide Image Placeholder 1"/>
+          <p:cNvSpPr>
+            <a:spLocks noGrp="1" noRot="1" noChangeAspect="1"/>
+          </p:cNvSpPr>
+          <p:nvPr>
+            <p:ph type="sldImg"/>
+          </p:nvPr>
+        </p:nvSpPr>
+        <p:spPr/>
+      </p:sp>
+      <p:sp>
+        <p:nvSpPr>
+          <p:cNvPr id="3" name="Notes Placeholder 2"/>
+          <p:cNvSpPr>
+            <a:spLocks noGrp="1"/>
+          </p:cNvSpPr>
+          <p:nvPr>
+            <p:ph type="body" idx="1"/>
+          </p:nvPr>
+        </p:nvSpPr>
+        <p:spPr/>
+        <p:txBody>
+          <a:bodyPr/>
+          <a:lstStyle/>
+          <a:p>
+            <a:endParaRPr lang="en-US" dirty="0"/>
+          </a:p>
+        </p:txBody>
+      </p:sp>
+      <p:sp>
+        <p:nvSpPr>
+          <p:cNvPr id="4" name="Slide Number Placeholder 3"/>
+          <p:cNvSpPr>
+            <a:spLocks noGrp="1"/>
+          </p:cNvSpPr>
+          <p:nvPr>
+            <p:ph type="sldNum" sz="quarter" idx="10"/>
+          </p:nvPr>
+        </p:nvSpPr>
+        <p:spPr/>
+        <p:txBody>
+          <a:bodyPr/>
+          <a:lstStyle/>
+          <a:p>
+            <a:fld id="{F7021451-1387-4CA6-816F-3879F97B5CBC}" type="slidenum">
+              <a:rPr lang="en-US"/>
+              <a:t>15</a:t>
+            </a:fld>
+            <a:endParaRPr lang="en-US"/>
+          </a:p>
+        </p:txBody>
+      </p:sp>
+    </p:spTree>
+    <p:extLst>
+      <p:ext uri="{BB962C8B-B14F-4D97-AF65-F5344CB8AC3E}">
+        <p14:creationId xmlns:p14="http://schemas.microsoft.com/office/powerpoint/2010/main" val="1024086991"/>
+      </p:ext>
+    </p:extLst>
+  </p:cSld>
+  <p:clrMapOvr>
+    <a:masterClrMapping/>
+  </p:clrMapOvr>
+</p:notes>
+</file>
+
+<file path=ppt/notesSlides/notesSlide16.xml><?xml version="1.0" encoding="utf-8"?>
+<p:notes xmlns:a="http://schemas.openxmlformats.org/drawingml/2006/main" xmlns:r="http://schemas.openxmlformats.org/officeDocument/2006/relationships" xmlns:p="http://schemas.openxmlformats.org/presentationml/2006/main">
+  <p:cSld>
+    <p:spTree>
+      <p:nvGrpSpPr>
+        <p:cNvPr id="1" name=""/>
+        <p:cNvGrpSpPr/>
+        <p:nvPr/>
+      </p:nvGrpSpPr>
+      <p:grpSpPr>
+        <a:xfrm>
+          <a:off x="0" y="0"/>
+          <a:ext cx="0" cy="0"/>
+          <a:chOff x="0" y="0"/>
+          <a:chExt cx="0" cy="0"/>
+        </a:xfrm>
+      </p:grpSpPr>
+      <p:sp>
+        <p:nvSpPr>
+          <p:cNvPr id="2" name="Slide Image Placeholder 1"/>
+          <p:cNvSpPr>
+            <a:spLocks noGrp="1" noRot="1" noChangeAspect="1"/>
+          </p:cNvSpPr>
+          <p:nvPr>
+            <p:ph type="sldImg"/>
+          </p:nvPr>
+        </p:nvSpPr>
+        <p:spPr/>
+      </p:sp>
+      <p:sp>
+        <p:nvSpPr>
+          <p:cNvPr id="3" name="Notes Placeholder 2"/>
+          <p:cNvSpPr>
+            <a:spLocks noGrp="1"/>
+          </p:cNvSpPr>
+          <p:nvPr>
+            <p:ph type="body" idx="1"/>
+          </p:nvPr>
+        </p:nvSpPr>
+        <p:spPr/>
+        <p:txBody>
+          <a:bodyPr/>
+          <a:lstStyle/>
+          <a:p>
+            <a:endParaRPr lang="en-US" dirty="0"/>
+          </a:p>
+        </p:txBody>
+      </p:sp>
+      <p:sp>
+        <p:nvSpPr>
+          <p:cNvPr id="4" name="Slide Number Placeholder 3"/>
+          <p:cNvSpPr>
+            <a:spLocks noGrp="1"/>
+          </p:cNvSpPr>
+          <p:nvPr>
+            <p:ph type="sldNum" sz="quarter" idx="10"/>
+          </p:nvPr>
+        </p:nvSpPr>
+        <p:spPr/>
+        <p:txBody>
+          <a:bodyPr/>
+          <a:lstStyle/>
+          <a:p>
+            <a:fld id="{F7021451-1387-4CA6-816F-3879F97B5CBC}" type="slidenum">
+              <a:rPr lang="en-US"/>
+              <a:t>16</a:t>
+            </a:fld>
+            <a:endParaRPr lang="en-US"/>
+          </a:p>
+        </p:txBody>
+      </p:sp>
+    </p:spTree>
+    <p:extLst>
+      <p:ext uri="{BB962C8B-B14F-4D97-AF65-F5344CB8AC3E}">
+        <p14:creationId xmlns:p14="http://schemas.microsoft.com/office/powerpoint/2010/main" val="1024086991"/>
+      </p:ext>
+    </p:extLst>
+  </p:cSld>
+  <p:clrMapOvr>
+    <a:masterClrMapping/>
+  </p:clrMapOvr>
+</p:notes>
+</file>
+
+<file path=ppt/notesSlides/notesSlide17.xml><?xml version="1.0" encoding="utf-8"?>
+<p:notes xmlns:a="http://schemas.openxmlformats.org/drawingml/2006/main" xmlns:r="http://schemas.openxmlformats.org/officeDocument/2006/relationships" xmlns:p="http://schemas.openxmlformats.org/presentationml/2006/main">
+  <p:cSld>
+    <p:spTree>
+      <p:nvGrpSpPr>
         <p:cNvPr id="1" name="">
           <a:extLst>
             <a:ext uri="{FF2B5EF4-FFF2-40B4-BE49-F238E27FC236}">
@@ -844,7 +1074,7 @@
           <a:p>
             <a:fld id="{F7021451-1387-4CA6-816F-3879F97B5CBC}" type="slidenum">
               <a:rPr lang="en-US"/>
-              <a:t>15</a:t>
+              <a:t>17</a:t>
             </a:fld>
             <a:endParaRPr lang="en-US"/>
           </a:p>
@@ -868,7 +1098,13 @@
   <p:cSld>
     <p:spTree>
       <p:nvGrpSpPr>
-        <p:cNvPr id="1" name=""/>
+        <p:cNvPr id="1" name="">
+          <a:extLst>
+            <a:ext uri="{FF2B5EF4-FFF2-40B4-BE49-F238E27FC236}">
+              <a16:creationId xmlns:a16="http://schemas.microsoft.com/office/drawing/2014/main" id="{87E77159-EF10-4E58-8A27-C51367896444}"/>
+            </a:ext>
+          </a:extLst>
+        </p:cNvPr>
         <p:cNvGrpSpPr/>
         <p:nvPr/>
       </p:nvGrpSpPr>
@@ -882,7 +1118,13 @@
       </p:grpSpPr>
       <p:sp>
         <p:nvSpPr>
-          <p:cNvPr id="2" name="Slide Image Placeholder 1"/>
+          <p:cNvPr id="2" name="Slide Image Placeholder 1">
+            <a:extLst>
+              <a:ext uri="{FF2B5EF4-FFF2-40B4-BE49-F238E27FC236}">
+                <a16:creationId xmlns:a16="http://schemas.microsoft.com/office/drawing/2014/main" id="{E2108AB1-C6D7-9ED4-F9DE-4E361DE83503}"/>
+              </a:ext>
+            </a:extLst>
+          </p:cNvPr>
           <p:cNvSpPr>
             <a:spLocks noGrp="1" noRot="1" noChangeAspect="1"/>
           </p:cNvSpPr>
@@ -894,7 +1136,13 @@
       </p:sp>
       <p:sp>
         <p:nvSpPr>
-          <p:cNvPr id="3" name="Notes Placeholder 2"/>
+          <p:cNvPr id="3" name="Notes Placeholder 2">
+            <a:extLst>
+              <a:ext uri="{FF2B5EF4-FFF2-40B4-BE49-F238E27FC236}">
+                <a16:creationId xmlns:a16="http://schemas.microsoft.com/office/drawing/2014/main" id="{ED68CCCD-10B1-C935-1237-86D1E933A6AE}"/>
+              </a:ext>
+            </a:extLst>
+          </p:cNvPr>
           <p:cNvSpPr>
             <a:spLocks noGrp="1"/>
           </p:cNvSpPr>
@@ -913,7 +1161,13 @@
       </p:sp>
       <p:sp>
         <p:nvSpPr>
-          <p:cNvPr id="4" name="Slide Number Placeholder 3"/>
+          <p:cNvPr id="4" name="Slide Number Placeholder 3">
+            <a:extLst>
+              <a:ext uri="{FF2B5EF4-FFF2-40B4-BE49-F238E27FC236}">
+                <a16:creationId xmlns:a16="http://schemas.microsoft.com/office/drawing/2014/main" id="{0DF13871-33E6-83FD-B70E-E9C3CD45CB07}"/>
+              </a:ext>
+            </a:extLst>
+          </p:cNvPr>
           <p:cNvSpPr>
             <a:spLocks noGrp="1"/>
           </p:cNvSpPr>
@@ -937,7 +1191,7 @@
     </p:spTree>
     <p:extLst>
       <p:ext uri="{BB962C8B-B14F-4D97-AF65-F5344CB8AC3E}">
-        <p14:creationId xmlns:p14="http://schemas.microsoft.com/office/powerpoint/2010/main" val="1024086991"/>
+        <p14:creationId xmlns:p14="http://schemas.microsoft.com/office/powerpoint/2010/main" val="1030234277"/>
       </p:ext>
     </p:extLst>
   </p:cSld>
@@ -2131,6 +2385,3333 @@
 
 <file path=ppt/slides/slide10.xml><?xml version="1.0" encoding="utf-8"?>
 <p:sld xmlns:a="http://schemas.openxmlformats.org/drawingml/2006/main" xmlns:r="http://schemas.openxmlformats.org/officeDocument/2006/relationships" xmlns:p="http://schemas.openxmlformats.org/presentationml/2006/main">
+  <p:cSld>
+    <p:bg>
+      <p:bgPr>
+        <a:solidFill>
+          <a:srgbClr val="F0F4F8"/>
+        </a:solidFill>
+        <a:effectLst/>
+      </p:bgPr>
+    </p:bg>
+    <p:spTree>
+      <p:nvGrpSpPr>
+        <p:cNvPr id="1" name=""/>
+        <p:cNvGrpSpPr/>
+        <p:nvPr/>
+      </p:nvGrpSpPr>
+      <p:grpSpPr>
+        <a:xfrm>
+          <a:off x="0" y="0"/>
+          <a:ext cx="0" cy="0"/>
+          <a:chOff x="0" y="0"/>
+          <a:chExt cx="0" cy="0"/>
+        </a:xfrm>
+      </p:grpSpPr>
+      <p:sp>
+        <p:nvSpPr>
+          <p:cNvPr id="2" name="Shape 0"/>
+          <p:cNvSpPr/>
+          <p:nvPr/>
+        </p:nvSpPr>
+        <p:spPr>
+          <a:xfrm>
+            <a:off x="0" y="0"/>
+            <a:ext cx="9144000" cy="1005840"/>
+          </a:xfrm>
+          <a:prstGeom prst="rect">
+            <a:avLst/>
+          </a:prstGeom>
+          <a:solidFill>
+            <a:schemeClr val="accent1">
+              <a:lumMod val="50000"/>
+            </a:schemeClr>
+          </a:solidFill>
+          <a:ln/>
+        </p:spPr>
+      </p:sp>
+      <p:sp>
+        <p:nvSpPr>
+          <p:cNvPr id="3" name="Text 1"/>
+          <p:cNvSpPr/>
+          <p:nvPr/>
+        </p:nvSpPr>
+        <p:spPr>
+          <a:xfrm>
+            <a:off x="457200" y="182880"/>
+            <a:ext cx="8229600" cy="640080"/>
+          </a:xfrm>
+          <a:prstGeom prst="rect">
+            <a:avLst/>
+          </a:prstGeom>
+          <a:noFill/>
+          <a:ln/>
+        </p:spPr>
+        <p:txBody>
+          <a:bodyPr wrap="square" rtlCol="0" anchor="ctr"/>
+          <a:lstStyle/>
+          <a:p>
+            <a:pPr marL="0" marR="0" lvl="0" indent="0" algn="l" defTabSz="914400" rtl="0" eaLnBrk="1" fontAlgn="auto" latinLnBrk="0" hangingPunct="1">
+              <a:lnSpc>
+                <a:spcPct val="100000"/>
+              </a:lnSpc>
+              <a:spcBef>
+                <a:spcPts val="0"/>
+              </a:spcBef>
+              <a:spcAft>
+                <a:spcPts val="0"/>
+              </a:spcAft>
+              <a:buClrTx/>
+              <a:buSzTx/>
+              <a:buFontTx/>
+              <a:buNone/>
+              <a:tabLst/>
+              <a:defRPr/>
+            </a:pPr>
+            <a:r>
+              <a:rPr kumimoji="0" lang="en-US" sz="2200" b="1" i="0" u="none" strike="noStrike" kern="1200" cap="none" spc="0" normalizeH="0" baseline="0" noProof="0" dirty="0">
+                <a:ln>
+                  <a:noFill/>
+                </a:ln>
+                <a:solidFill>
+                  <a:srgbClr val="FFFFFF"/>
+                </a:solidFill>
+                <a:effectLst/>
+                <a:uLnTx/>
+                <a:uFillTx/>
+                <a:latin typeface="Calibri" panose="020F0502020204030204"/>
+                <a:ea typeface="+mn-ea"/>
+                <a:cs typeface="+mn-cs"/>
+              </a:rPr>
+              <a:t>EVALUATING OUR MODEL PROPERLY</a:t>
+            </a:r>
+            <a:endParaRPr kumimoji="0" lang="en-US" sz="2200" b="0" i="0" u="none" strike="noStrike" kern="1200" cap="none" spc="0" normalizeH="0" baseline="0" noProof="0" dirty="0">
+              <a:ln>
+                <a:noFill/>
+              </a:ln>
+              <a:solidFill>
+                <a:prstClr val="black"/>
+              </a:solidFill>
+              <a:effectLst/>
+              <a:uLnTx/>
+              <a:uFillTx/>
+              <a:latin typeface="Calibri" panose="020F0502020204030204"/>
+              <a:ea typeface="+mn-ea"/>
+              <a:cs typeface="+mn-cs"/>
+            </a:endParaRPr>
+          </a:p>
+        </p:txBody>
+      </p:sp>
+      <p:sp>
+        <p:nvSpPr>
+          <p:cNvPr id="4" name="Text 2"/>
+          <p:cNvSpPr/>
+          <p:nvPr/>
+        </p:nvSpPr>
+        <p:spPr>
+          <a:xfrm>
+            <a:off x="274320" y="1051560"/>
+            <a:ext cx="8595360" cy="320040"/>
+          </a:xfrm>
+          <a:prstGeom prst="rect">
+            <a:avLst/>
+          </a:prstGeom>
+          <a:noFill/>
+          <a:ln/>
+        </p:spPr>
+        <p:txBody>
+          <a:bodyPr wrap="square" rtlCol="0" anchor="ctr"/>
+          <a:lstStyle/>
+          <a:p>
+            <a:pPr marL="0" marR="0" lvl="0" indent="0" algn="l" defTabSz="914400" rtl="0" eaLnBrk="1" fontAlgn="auto" latinLnBrk="0" hangingPunct="1">
+              <a:lnSpc>
+                <a:spcPct val="100000"/>
+              </a:lnSpc>
+              <a:spcBef>
+                <a:spcPts val="0"/>
+              </a:spcBef>
+              <a:spcAft>
+                <a:spcPts val="0"/>
+              </a:spcAft>
+              <a:buClrTx/>
+              <a:buSzTx/>
+              <a:buFontTx/>
+              <a:buNone/>
+              <a:tabLst/>
+              <a:defRPr/>
+            </a:pPr>
+            <a:r>
+              <a:rPr kumimoji="0" lang="en-US" sz="1200" b="1" i="1" u="none" strike="noStrike" kern="1200" cap="none" spc="0" normalizeH="0" baseline="0" noProof="0" dirty="0">
+                <a:ln>
+                  <a:noFill/>
+                </a:ln>
+                <a:solidFill>
+                  <a:srgbClr val="8B4513"/>
+                </a:solidFill>
+                <a:effectLst/>
+                <a:uLnTx/>
+                <a:uFillTx/>
+                <a:latin typeface="Calibri" panose="020F0502020204030204"/>
+                <a:ea typeface="+mn-ea"/>
+                <a:cs typeface="+mn-cs"/>
+              </a:rPr>
+              <a:t>Beyond ROC AUC — Four Additional Evaluation Factors</a:t>
+            </a:r>
+            <a:endParaRPr kumimoji="0" lang="en-US" sz="1200" b="0" i="0" u="none" strike="noStrike" kern="1200" cap="none" spc="0" normalizeH="0" baseline="0" noProof="0" dirty="0">
+              <a:ln>
+                <a:noFill/>
+              </a:ln>
+              <a:solidFill>
+                <a:prstClr val="black"/>
+              </a:solidFill>
+              <a:effectLst/>
+              <a:uLnTx/>
+              <a:uFillTx/>
+              <a:latin typeface="Calibri" panose="020F0502020204030204"/>
+              <a:ea typeface="+mn-ea"/>
+              <a:cs typeface="+mn-cs"/>
+            </a:endParaRPr>
+          </a:p>
+        </p:txBody>
+      </p:sp>
+      <p:sp>
+        <p:nvSpPr>
+          <p:cNvPr id="5" name="Shape 3"/>
+          <p:cNvSpPr/>
+          <p:nvPr/>
+        </p:nvSpPr>
+        <p:spPr>
+          <a:xfrm>
+            <a:off x="274320" y="1417320"/>
+            <a:ext cx="2011680" cy="347472"/>
+          </a:xfrm>
+          <a:prstGeom prst="rect">
+            <a:avLst/>
+          </a:prstGeom>
+          <a:solidFill>
+            <a:schemeClr val="accent1">
+              <a:lumMod val="50000"/>
+            </a:schemeClr>
+          </a:solidFill>
+          <a:ln/>
+        </p:spPr>
+      </p:sp>
+      <p:sp>
+        <p:nvSpPr>
+          <p:cNvPr id="6" name="Text 4"/>
+          <p:cNvSpPr/>
+          <p:nvPr/>
+        </p:nvSpPr>
+        <p:spPr>
+          <a:xfrm>
+            <a:off x="320040" y="1463040"/>
+            <a:ext cx="1920240" cy="256032"/>
+          </a:xfrm>
+          <a:prstGeom prst="rect">
+            <a:avLst/>
+          </a:prstGeom>
+          <a:noFill/>
+          <a:ln/>
+        </p:spPr>
+        <p:txBody>
+          <a:bodyPr wrap="square" lIns="0" tIns="0" rIns="0" bIns="0" rtlCol="0" anchor="ctr"/>
+          <a:lstStyle/>
+          <a:p>
+            <a:pPr marL="0" marR="0" lvl="0" indent="0" algn="ctr" defTabSz="914400" rtl="0" eaLnBrk="1" fontAlgn="auto" latinLnBrk="0" hangingPunct="1">
+              <a:lnSpc>
+                <a:spcPct val="100000"/>
+              </a:lnSpc>
+              <a:spcBef>
+                <a:spcPts val="0"/>
+              </a:spcBef>
+              <a:spcAft>
+                <a:spcPts val="0"/>
+              </a:spcAft>
+              <a:buClrTx/>
+              <a:buSzTx/>
+              <a:buFontTx/>
+              <a:buNone/>
+              <a:tabLst/>
+              <a:defRPr/>
+            </a:pPr>
+            <a:r>
+              <a:rPr kumimoji="0" lang="en-US" sz="1000" b="1" i="0" u="none" strike="noStrike" kern="1200" cap="none" spc="0" normalizeH="0" baseline="0" noProof="0" dirty="0">
+                <a:ln>
+                  <a:noFill/>
+                </a:ln>
+                <a:solidFill>
+                  <a:srgbClr val="FFFFFF"/>
+                </a:solidFill>
+                <a:effectLst/>
+                <a:uLnTx/>
+                <a:uFillTx/>
+                <a:latin typeface="Calibri" panose="020F0502020204030204"/>
+                <a:ea typeface="+mn-ea"/>
+                <a:cs typeface="+mn-cs"/>
+              </a:rPr>
+              <a:t>Factor</a:t>
+            </a:r>
+            <a:endParaRPr kumimoji="0" lang="en-US" sz="1000" b="0" i="0" u="none" strike="noStrike" kern="1200" cap="none" spc="0" normalizeH="0" baseline="0" noProof="0" dirty="0">
+              <a:ln>
+                <a:noFill/>
+              </a:ln>
+              <a:solidFill>
+                <a:prstClr val="black"/>
+              </a:solidFill>
+              <a:effectLst/>
+              <a:uLnTx/>
+              <a:uFillTx/>
+              <a:latin typeface="Calibri" panose="020F0502020204030204"/>
+              <a:ea typeface="+mn-ea"/>
+              <a:cs typeface="+mn-cs"/>
+            </a:endParaRPr>
+          </a:p>
+        </p:txBody>
+      </p:sp>
+      <p:sp>
+        <p:nvSpPr>
+          <p:cNvPr id="7" name="Shape 5"/>
+          <p:cNvSpPr/>
+          <p:nvPr/>
+        </p:nvSpPr>
+        <p:spPr>
+          <a:xfrm>
+            <a:off x="2286000" y="1417320"/>
+            <a:ext cx="2011680" cy="347472"/>
+          </a:xfrm>
+          <a:prstGeom prst="rect">
+            <a:avLst/>
+          </a:prstGeom>
+          <a:solidFill>
+            <a:srgbClr val="006400"/>
+          </a:solidFill>
+          <a:ln/>
+        </p:spPr>
+      </p:sp>
+      <p:sp>
+        <p:nvSpPr>
+          <p:cNvPr id="8" name="Text 6"/>
+          <p:cNvSpPr/>
+          <p:nvPr/>
+        </p:nvSpPr>
+        <p:spPr>
+          <a:xfrm>
+            <a:off x="2331720" y="1463040"/>
+            <a:ext cx="1920240" cy="256032"/>
+          </a:xfrm>
+          <a:prstGeom prst="rect">
+            <a:avLst/>
+          </a:prstGeom>
+          <a:noFill/>
+          <a:ln/>
+        </p:spPr>
+        <p:txBody>
+          <a:bodyPr wrap="square" lIns="0" tIns="0" rIns="0" bIns="0" rtlCol="0" anchor="ctr"/>
+          <a:lstStyle/>
+          <a:p>
+            <a:pPr marL="0" marR="0" lvl="0" indent="0" algn="ctr" defTabSz="914400" rtl="0" eaLnBrk="1" fontAlgn="auto" latinLnBrk="0" hangingPunct="1">
+              <a:lnSpc>
+                <a:spcPct val="100000"/>
+              </a:lnSpc>
+              <a:spcBef>
+                <a:spcPts val="0"/>
+              </a:spcBef>
+              <a:spcAft>
+                <a:spcPts val="0"/>
+              </a:spcAft>
+              <a:buClrTx/>
+              <a:buSzTx/>
+              <a:buFontTx/>
+              <a:buNone/>
+              <a:tabLst/>
+              <a:defRPr/>
+            </a:pPr>
+            <a:r>
+              <a:rPr kumimoji="0" lang="en-US" sz="1000" b="1" i="0" u="none" strike="noStrike" kern="1200" cap="none" spc="0" normalizeH="0" baseline="0" noProof="0" dirty="0">
+                <a:ln>
+                  <a:noFill/>
+                </a:ln>
+                <a:solidFill>
+                  <a:srgbClr val="FFFFFF"/>
+                </a:solidFill>
+                <a:effectLst/>
+                <a:uLnTx/>
+                <a:uFillTx/>
+                <a:latin typeface="Calibri" panose="020F0502020204030204"/>
+                <a:ea typeface="+mn-ea"/>
+                <a:cs typeface="+mn-cs"/>
+              </a:rPr>
+              <a:t>Random Forest</a:t>
+            </a:r>
+            <a:endParaRPr kumimoji="0" lang="en-US" sz="1000" b="0" i="0" u="none" strike="noStrike" kern="1200" cap="none" spc="0" normalizeH="0" baseline="0" noProof="0" dirty="0">
+              <a:ln>
+                <a:noFill/>
+              </a:ln>
+              <a:solidFill>
+                <a:prstClr val="black"/>
+              </a:solidFill>
+              <a:effectLst/>
+              <a:uLnTx/>
+              <a:uFillTx/>
+              <a:latin typeface="Calibri" panose="020F0502020204030204"/>
+              <a:ea typeface="+mn-ea"/>
+              <a:cs typeface="+mn-cs"/>
+            </a:endParaRPr>
+          </a:p>
+        </p:txBody>
+      </p:sp>
+      <p:sp>
+        <p:nvSpPr>
+          <p:cNvPr id="9" name="Shape 7"/>
+          <p:cNvSpPr/>
+          <p:nvPr/>
+        </p:nvSpPr>
+        <p:spPr>
+          <a:xfrm>
+            <a:off x="4297680" y="1417320"/>
+            <a:ext cx="2011680" cy="347472"/>
+          </a:xfrm>
+          <a:prstGeom prst="rect">
+            <a:avLst/>
+          </a:prstGeom>
+          <a:solidFill>
+            <a:srgbClr val="0F1F3D"/>
+          </a:solidFill>
+          <a:ln/>
+        </p:spPr>
+      </p:sp>
+      <p:sp>
+        <p:nvSpPr>
+          <p:cNvPr id="10" name="Text 8"/>
+          <p:cNvSpPr/>
+          <p:nvPr/>
+        </p:nvSpPr>
+        <p:spPr>
+          <a:xfrm>
+            <a:off x="4343400" y="1463040"/>
+            <a:ext cx="1920240" cy="256032"/>
+          </a:xfrm>
+          <a:prstGeom prst="rect">
+            <a:avLst/>
+          </a:prstGeom>
+          <a:noFill/>
+          <a:ln/>
+        </p:spPr>
+        <p:txBody>
+          <a:bodyPr wrap="square" lIns="0" tIns="0" rIns="0" bIns="0" rtlCol="0" anchor="ctr"/>
+          <a:lstStyle/>
+          <a:p>
+            <a:pPr marL="0" marR="0" lvl="0" indent="0" algn="ctr" defTabSz="914400" rtl="0" eaLnBrk="1" fontAlgn="auto" latinLnBrk="0" hangingPunct="1">
+              <a:lnSpc>
+                <a:spcPct val="100000"/>
+              </a:lnSpc>
+              <a:spcBef>
+                <a:spcPts val="0"/>
+              </a:spcBef>
+              <a:spcAft>
+                <a:spcPts val="0"/>
+              </a:spcAft>
+              <a:buClrTx/>
+              <a:buSzTx/>
+              <a:buFontTx/>
+              <a:buNone/>
+              <a:tabLst/>
+              <a:defRPr/>
+            </a:pPr>
+            <a:r>
+              <a:rPr kumimoji="0" lang="en-US" sz="1000" b="1" i="0" u="none" strike="noStrike" kern="1200" cap="none" spc="0" normalizeH="0" baseline="0" noProof="0" dirty="0">
+                <a:ln>
+                  <a:noFill/>
+                </a:ln>
+                <a:solidFill>
+                  <a:srgbClr val="FFFFFF"/>
+                </a:solidFill>
+                <a:effectLst/>
+                <a:uLnTx/>
+                <a:uFillTx/>
+                <a:latin typeface="Calibri" panose="020F0502020204030204"/>
+                <a:ea typeface="+mn-ea"/>
+                <a:cs typeface="+mn-cs"/>
+              </a:rPr>
+              <a:t>Logistic Regression</a:t>
+            </a:r>
+            <a:endParaRPr kumimoji="0" lang="en-US" sz="1000" b="0" i="0" u="none" strike="noStrike" kern="1200" cap="none" spc="0" normalizeH="0" baseline="0" noProof="0" dirty="0">
+              <a:ln>
+                <a:noFill/>
+              </a:ln>
+              <a:solidFill>
+                <a:prstClr val="black"/>
+              </a:solidFill>
+              <a:effectLst/>
+              <a:uLnTx/>
+              <a:uFillTx/>
+              <a:latin typeface="Calibri" panose="020F0502020204030204"/>
+              <a:ea typeface="+mn-ea"/>
+              <a:cs typeface="+mn-cs"/>
+            </a:endParaRPr>
+          </a:p>
+        </p:txBody>
+      </p:sp>
+      <p:sp>
+        <p:nvSpPr>
+          <p:cNvPr id="11" name="Shape 9"/>
+          <p:cNvSpPr/>
+          <p:nvPr/>
+        </p:nvSpPr>
+        <p:spPr>
+          <a:xfrm>
+            <a:off x="274320" y="1764792"/>
+            <a:ext cx="2011680" cy="347472"/>
+          </a:xfrm>
+          <a:prstGeom prst="rect">
+            <a:avLst/>
+          </a:prstGeom>
+          <a:solidFill>
+            <a:srgbClr val="FFFFFF"/>
+          </a:solidFill>
+          <a:ln/>
+        </p:spPr>
+      </p:sp>
+      <p:sp>
+        <p:nvSpPr>
+          <p:cNvPr id="12" name="Text 10"/>
+          <p:cNvSpPr/>
+          <p:nvPr/>
+        </p:nvSpPr>
+        <p:spPr>
+          <a:xfrm>
+            <a:off x="320040" y="1810512"/>
+            <a:ext cx="1920240" cy="256032"/>
+          </a:xfrm>
+          <a:prstGeom prst="rect">
+            <a:avLst/>
+          </a:prstGeom>
+          <a:noFill/>
+          <a:ln/>
+        </p:spPr>
+        <p:txBody>
+          <a:bodyPr wrap="square" lIns="0" tIns="0" rIns="0" bIns="0" rtlCol="0" anchor="ctr"/>
+          <a:lstStyle/>
+          <a:p>
+            <a:pPr marL="0" marR="0" lvl="0" indent="0" algn="l" defTabSz="914400" rtl="0" eaLnBrk="1" fontAlgn="auto" latinLnBrk="0" hangingPunct="1">
+              <a:lnSpc>
+                <a:spcPct val="100000"/>
+              </a:lnSpc>
+              <a:spcBef>
+                <a:spcPts val="0"/>
+              </a:spcBef>
+              <a:spcAft>
+                <a:spcPts val="0"/>
+              </a:spcAft>
+              <a:buClrTx/>
+              <a:buSzTx/>
+              <a:buFontTx/>
+              <a:buNone/>
+              <a:tabLst/>
+              <a:defRPr/>
+            </a:pPr>
+            <a:r>
+              <a:rPr kumimoji="0" lang="en-US" sz="1000" b="0" i="0" u="none" strike="noStrike" kern="1200" cap="none" spc="0" normalizeH="0" baseline="0" noProof="0" dirty="0">
+                <a:ln>
+                  <a:noFill/>
+                </a:ln>
+                <a:solidFill>
+                  <a:srgbClr val="0F1F3D"/>
+                </a:solidFill>
+                <a:effectLst/>
+                <a:uLnTx/>
+                <a:uFillTx/>
+                <a:latin typeface="Calibri" panose="020F0502020204030204"/>
+                <a:ea typeface="+mn-ea"/>
+                <a:cs typeface="+mn-cs"/>
+              </a:rPr>
+              <a:t>ROC AUC</a:t>
+            </a:r>
+            <a:endParaRPr kumimoji="0" lang="en-US" sz="1000" b="0" i="0" u="none" strike="noStrike" kern="1200" cap="none" spc="0" normalizeH="0" baseline="0" noProof="0" dirty="0">
+              <a:ln>
+                <a:noFill/>
+              </a:ln>
+              <a:solidFill>
+                <a:prstClr val="black"/>
+              </a:solidFill>
+              <a:effectLst/>
+              <a:uLnTx/>
+              <a:uFillTx/>
+              <a:latin typeface="Calibri" panose="020F0502020204030204"/>
+              <a:ea typeface="+mn-ea"/>
+              <a:cs typeface="+mn-cs"/>
+            </a:endParaRPr>
+          </a:p>
+        </p:txBody>
+      </p:sp>
+      <p:sp>
+        <p:nvSpPr>
+          <p:cNvPr id="13" name="Shape 11"/>
+          <p:cNvSpPr/>
+          <p:nvPr/>
+        </p:nvSpPr>
+        <p:spPr>
+          <a:xfrm>
+            <a:off x="2286000" y="1764792"/>
+            <a:ext cx="2011680" cy="347472"/>
+          </a:xfrm>
+          <a:prstGeom prst="rect">
+            <a:avLst/>
+          </a:prstGeom>
+          <a:solidFill>
+            <a:srgbClr val="FFFFFF"/>
+          </a:solidFill>
+          <a:ln/>
+        </p:spPr>
+      </p:sp>
+      <p:sp>
+        <p:nvSpPr>
+          <p:cNvPr id="14" name="Text 12"/>
+          <p:cNvSpPr/>
+          <p:nvPr/>
+        </p:nvSpPr>
+        <p:spPr>
+          <a:xfrm>
+            <a:off x="2331720" y="1810512"/>
+            <a:ext cx="1920240" cy="256032"/>
+          </a:xfrm>
+          <a:prstGeom prst="rect">
+            <a:avLst/>
+          </a:prstGeom>
+          <a:noFill/>
+          <a:ln/>
+        </p:spPr>
+        <p:txBody>
+          <a:bodyPr wrap="square" lIns="0" tIns="0" rIns="0" bIns="0" rtlCol="0" anchor="ctr"/>
+          <a:lstStyle/>
+          <a:p>
+            <a:pPr marL="0" marR="0" lvl="0" indent="0" algn="ctr" defTabSz="914400" rtl="0" eaLnBrk="1" fontAlgn="auto" latinLnBrk="0" hangingPunct="1">
+              <a:lnSpc>
+                <a:spcPct val="100000"/>
+              </a:lnSpc>
+              <a:spcBef>
+                <a:spcPts val="0"/>
+              </a:spcBef>
+              <a:spcAft>
+                <a:spcPts val="0"/>
+              </a:spcAft>
+              <a:buClrTx/>
+              <a:buSzTx/>
+              <a:buFontTx/>
+              <a:buNone/>
+              <a:tabLst/>
+              <a:defRPr/>
+            </a:pPr>
+            <a:r>
+              <a:rPr kumimoji="0" lang="en-US" sz="1000" b="1" i="0" u="none" strike="noStrike" kern="1200" cap="none" spc="0" normalizeH="0" baseline="0" noProof="0" dirty="0">
+                <a:ln>
+                  <a:noFill/>
+                </a:ln>
+                <a:solidFill>
+                  <a:srgbClr val="006400"/>
+                </a:solidFill>
+                <a:effectLst/>
+                <a:uLnTx/>
+                <a:uFillTx/>
+                <a:latin typeface="Calibri" panose="020F0502020204030204"/>
+                <a:ea typeface="+mn-ea"/>
+                <a:cs typeface="+mn-cs"/>
+              </a:rPr>
+              <a:t>0.8518 </a:t>
+            </a:r>
+            <a:endParaRPr kumimoji="0" lang="en-US" sz="1000" b="0" i="0" u="none" strike="noStrike" kern="1200" cap="none" spc="0" normalizeH="0" baseline="0" noProof="0" dirty="0">
+              <a:ln>
+                <a:noFill/>
+              </a:ln>
+              <a:solidFill>
+                <a:prstClr val="black"/>
+              </a:solidFill>
+              <a:effectLst/>
+              <a:uLnTx/>
+              <a:uFillTx/>
+              <a:latin typeface="Calibri" panose="020F0502020204030204"/>
+              <a:ea typeface="+mn-ea"/>
+              <a:cs typeface="+mn-cs"/>
+            </a:endParaRPr>
+          </a:p>
+        </p:txBody>
+      </p:sp>
+      <p:sp>
+        <p:nvSpPr>
+          <p:cNvPr id="15" name="Shape 13"/>
+          <p:cNvSpPr/>
+          <p:nvPr/>
+        </p:nvSpPr>
+        <p:spPr>
+          <a:xfrm>
+            <a:off x="4297680" y="1764792"/>
+            <a:ext cx="2011680" cy="347472"/>
+          </a:xfrm>
+          <a:prstGeom prst="rect">
+            <a:avLst/>
+          </a:prstGeom>
+          <a:solidFill>
+            <a:srgbClr val="FFFFFF"/>
+          </a:solidFill>
+          <a:ln/>
+        </p:spPr>
+      </p:sp>
+      <p:sp>
+        <p:nvSpPr>
+          <p:cNvPr id="16" name="Text 14"/>
+          <p:cNvSpPr/>
+          <p:nvPr/>
+        </p:nvSpPr>
+        <p:spPr>
+          <a:xfrm>
+            <a:off x="4343400" y="1810512"/>
+            <a:ext cx="1920240" cy="256032"/>
+          </a:xfrm>
+          <a:prstGeom prst="rect">
+            <a:avLst/>
+          </a:prstGeom>
+          <a:noFill/>
+          <a:ln/>
+        </p:spPr>
+        <p:txBody>
+          <a:bodyPr wrap="square" lIns="0" tIns="0" rIns="0" bIns="0" rtlCol="0" anchor="ctr"/>
+          <a:lstStyle/>
+          <a:p>
+            <a:pPr marL="0" marR="0" lvl="0" indent="0" algn="ctr" defTabSz="914400" rtl="0" eaLnBrk="1" fontAlgn="auto" latinLnBrk="0" hangingPunct="1">
+              <a:lnSpc>
+                <a:spcPct val="100000"/>
+              </a:lnSpc>
+              <a:spcBef>
+                <a:spcPts val="0"/>
+              </a:spcBef>
+              <a:spcAft>
+                <a:spcPts val="0"/>
+              </a:spcAft>
+              <a:buClrTx/>
+              <a:buSzTx/>
+              <a:buFontTx/>
+              <a:buNone/>
+              <a:tabLst/>
+              <a:defRPr/>
+            </a:pPr>
+            <a:r>
+              <a:rPr kumimoji="0" lang="en-US" sz="1000" b="0" i="0" u="none" strike="noStrike" kern="1200" cap="none" spc="0" normalizeH="0" baseline="0" noProof="0" dirty="0">
+                <a:ln>
+                  <a:noFill/>
+                </a:ln>
+                <a:solidFill>
+                  <a:srgbClr val="0F1F3D"/>
+                </a:solidFill>
+                <a:effectLst/>
+                <a:uLnTx/>
+                <a:uFillTx/>
+                <a:latin typeface="Calibri" panose="020F0502020204030204"/>
+                <a:ea typeface="+mn-ea"/>
+                <a:cs typeface="+mn-cs"/>
+              </a:rPr>
+              <a:t>0.8506</a:t>
+            </a:r>
+            <a:endParaRPr kumimoji="0" lang="en-US" sz="1000" b="0" i="0" u="none" strike="noStrike" kern="1200" cap="none" spc="0" normalizeH="0" baseline="0" noProof="0" dirty="0">
+              <a:ln>
+                <a:noFill/>
+              </a:ln>
+              <a:solidFill>
+                <a:prstClr val="black"/>
+              </a:solidFill>
+              <a:effectLst/>
+              <a:uLnTx/>
+              <a:uFillTx/>
+              <a:latin typeface="Calibri" panose="020F0502020204030204"/>
+              <a:ea typeface="+mn-ea"/>
+              <a:cs typeface="+mn-cs"/>
+            </a:endParaRPr>
+          </a:p>
+        </p:txBody>
+      </p:sp>
+      <p:sp>
+        <p:nvSpPr>
+          <p:cNvPr id="17" name="Shape 15"/>
+          <p:cNvSpPr/>
+          <p:nvPr/>
+        </p:nvSpPr>
+        <p:spPr>
+          <a:xfrm>
+            <a:off x="274320" y="2148840"/>
+            <a:ext cx="2011680" cy="347472"/>
+          </a:xfrm>
+          <a:prstGeom prst="rect">
+            <a:avLst/>
+          </a:prstGeom>
+          <a:solidFill>
+            <a:srgbClr val="F8F9FA"/>
+          </a:solidFill>
+          <a:ln/>
+        </p:spPr>
+      </p:sp>
+      <p:sp>
+        <p:nvSpPr>
+          <p:cNvPr id="18" name="Text 16"/>
+          <p:cNvSpPr/>
+          <p:nvPr/>
+        </p:nvSpPr>
+        <p:spPr>
+          <a:xfrm>
+            <a:off x="320040" y="2194560"/>
+            <a:ext cx="1920240" cy="256032"/>
+          </a:xfrm>
+          <a:prstGeom prst="rect">
+            <a:avLst/>
+          </a:prstGeom>
+          <a:noFill/>
+          <a:ln/>
+        </p:spPr>
+        <p:txBody>
+          <a:bodyPr wrap="square" lIns="0" tIns="0" rIns="0" bIns="0" rtlCol="0" anchor="ctr"/>
+          <a:lstStyle/>
+          <a:p>
+            <a:pPr marL="0" marR="0" lvl="0" indent="0" algn="l" defTabSz="914400" rtl="0" eaLnBrk="1" fontAlgn="auto" latinLnBrk="0" hangingPunct="1">
+              <a:lnSpc>
+                <a:spcPct val="100000"/>
+              </a:lnSpc>
+              <a:spcBef>
+                <a:spcPts val="0"/>
+              </a:spcBef>
+              <a:spcAft>
+                <a:spcPts val="0"/>
+              </a:spcAft>
+              <a:buClrTx/>
+              <a:buSzTx/>
+              <a:buFontTx/>
+              <a:buNone/>
+              <a:tabLst/>
+              <a:defRPr/>
+            </a:pPr>
+            <a:r>
+              <a:rPr kumimoji="0" lang="en-US" sz="1000" b="0" i="0" u="none" strike="noStrike" kern="1200" cap="none" spc="0" normalizeH="0" baseline="0" noProof="0" dirty="0">
+                <a:ln>
+                  <a:noFill/>
+                </a:ln>
+                <a:solidFill>
+                  <a:srgbClr val="0F1F3D"/>
+                </a:solidFill>
+                <a:effectLst/>
+                <a:uLnTx/>
+                <a:uFillTx/>
+                <a:latin typeface="Calibri" panose="020F0502020204030204"/>
+                <a:ea typeface="+mn-ea"/>
+                <a:cs typeface="+mn-cs"/>
+              </a:rPr>
+              <a:t>Runtime</a:t>
+            </a:r>
+            <a:endParaRPr kumimoji="0" lang="en-US" sz="1000" b="0" i="0" u="none" strike="noStrike" kern="1200" cap="none" spc="0" normalizeH="0" baseline="0" noProof="0" dirty="0">
+              <a:ln>
+                <a:noFill/>
+              </a:ln>
+              <a:solidFill>
+                <a:prstClr val="black"/>
+              </a:solidFill>
+              <a:effectLst/>
+              <a:uLnTx/>
+              <a:uFillTx/>
+              <a:latin typeface="Calibri" panose="020F0502020204030204"/>
+              <a:ea typeface="+mn-ea"/>
+              <a:cs typeface="+mn-cs"/>
+            </a:endParaRPr>
+          </a:p>
+        </p:txBody>
+      </p:sp>
+      <p:sp>
+        <p:nvSpPr>
+          <p:cNvPr id="19" name="Shape 17"/>
+          <p:cNvSpPr/>
+          <p:nvPr/>
+        </p:nvSpPr>
+        <p:spPr>
+          <a:xfrm>
+            <a:off x="2286000" y="2148840"/>
+            <a:ext cx="2011680" cy="347472"/>
+          </a:xfrm>
+          <a:prstGeom prst="rect">
+            <a:avLst/>
+          </a:prstGeom>
+          <a:solidFill>
+            <a:srgbClr val="F8F9FA"/>
+          </a:solidFill>
+          <a:ln/>
+        </p:spPr>
+      </p:sp>
+      <p:sp>
+        <p:nvSpPr>
+          <p:cNvPr id="20" name="Text 18"/>
+          <p:cNvSpPr/>
+          <p:nvPr/>
+        </p:nvSpPr>
+        <p:spPr>
+          <a:xfrm>
+            <a:off x="2331720" y="2194560"/>
+            <a:ext cx="1920240" cy="256032"/>
+          </a:xfrm>
+          <a:prstGeom prst="rect">
+            <a:avLst/>
+          </a:prstGeom>
+          <a:noFill/>
+          <a:ln/>
+        </p:spPr>
+        <p:txBody>
+          <a:bodyPr wrap="square" lIns="0" tIns="0" rIns="0" bIns="0" rtlCol="0" anchor="ctr"/>
+          <a:lstStyle/>
+          <a:p>
+            <a:pPr marL="0" marR="0" lvl="0" indent="0" algn="ctr" defTabSz="914400" rtl="0" eaLnBrk="1" fontAlgn="auto" latinLnBrk="0" hangingPunct="1">
+              <a:lnSpc>
+                <a:spcPct val="100000"/>
+              </a:lnSpc>
+              <a:spcBef>
+                <a:spcPts val="0"/>
+              </a:spcBef>
+              <a:spcAft>
+                <a:spcPts val="0"/>
+              </a:spcAft>
+              <a:buClrTx/>
+              <a:buSzTx/>
+              <a:buFontTx/>
+              <a:buNone/>
+              <a:tabLst/>
+              <a:defRPr/>
+            </a:pPr>
+            <a:r>
+              <a:rPr kumimoji="0" lang="en-US" sz="1000" b="1" i="0" u="none" strike="noStrike" kern="1200" cap="none" spc="0" normalizeH="0" baseline="0" noProof="0" dirty="0">
+                <a:ln>
+                  <a:noFill/>
+                </a:ln>
+                <a:solidFill>
+                  <a:srgbClr val="4A0000"/>
+                </a:solidFill>
+                <a:effectLst/>
+                <a:uLnTx/>
+                <a:uFillTx/>
+                <a:latin typeface="Calibri" panose="020F0502020204030204"/>
+                <a:ea typeface="+mn-ea"/>
+                <a:cs typeface="+mn-cs"/>
+              </a:rPr>
+              <a:t>Slow </a:t>
+            </a:r>
+            <a:endParaRPr kumimoji="0" lang="en-US" sz="1000" b="0" i="0" u="none" strike="noStrike" kern="1200" cap="none" spc="0" normalizeH="0" baseline="0" noProof="0" dirty="0">
+              <a:ln>
+                <a:noFill/>
+              </a:ln>
+              <a:solidFill>
+                <a:prstClr val="black"/>
+              </a:solidFill>
+              <a:effectLst/>
+              <a:uLnTx/>
+              <a:uFillTx/>
+              <a:latin typeface="Calibri" panose="020F0502020204030204"/>
+              <a:ea typeface="+mn-ea"/>
+              <a:cs typeface="+mn-cs"/>
+            </a:endParaRPr>
+          </a:p>
+        </p:txBody>
+      </p:sp>
+      <p:sp>
+        <p:nvSpPr>
+          <p:cNvPr id="21" name="Shape 19"/>
+          <p:cNvSpPr/>
+          <p:nvPr/>
+        </p:nvSpPr>
+        <p:spPr>
+          <a:xfrm>
+            <a:off x="4297680" y="2148840"/>
+            <a:ext cx="2011680" cy="347472"/>
+          </a:xfrm>
+          <a:prstGeom prst="rect">
+            <a:avLst/>
+          </a:prstGeom>
+          <a:solidFill>
+            <a:srgbClr val="F8F9FA"/>
+          </a:solidFill>
+          <a:ln/>
+        </p:spPr>
+      </p:sp>
+      <p:sp>
+        <p:nvSpPr>
+          <p:cNvPr id="22" name="Text 20"/>
+          <p:cNvSpPr/>
+          <p:nvPr/>
+        </p:nvSpPr>
+        <p:spPr>
+          <a:xfrm>
+            <a:off x="4343400" y="2194560"/>
+            <a:ext cx="1920240" cy="256032"/>
+          </a:xfrm>
+          <a:prstGeom prst="rect">
+            <a:avLst/>
+          </a:prstGeom>
+          <a:noFill/>
+          <a:ln/>
+        </p:spPr>
+        <p:txBody>
+          <a:bodyPr wrap="square" lIns="0" tIns="0" rIns="0" bIns="0" rtlCol="0" anchor="ctr"/>
+          <a:lstStyle/>
+          <a:p>
+            <a:pPr marL="0" marR="0" lvl="0" indent="0" algn="ctr" defTabSz="914400" rtl="0" eaLnBrk="1" fontAlgn="auto" latinLnBrk="0" hangingPunct="1">
+              <a:lnSpc>
+                <a:spcPct val="100000"/>
+              </a:lnSpc>
+              <a:spcBef>
+                <a:spcPts val="0"/>
+              </a:spcBef>
+              <a:spcAft>
+                <a:spcPts val="0"/>
+              </a:spcAft>
+              <a:buClrTx/>
+              <a:buSzTx/>
+              <a:buFontTx/>
+              <a:buNone/>
+              <a:tabLst/>
+              <a:defRPr/>
+            </a:pPr>
+            <a:r>
+              <a:rPr kumimoji="0" lang="en-US" sz="1000" b="1" i="0" u="none" strike="noStrike" kern="1200" cap="none" spc="0" normalizeH="0" baseline="0" noProof="0" dirty="0">
+                <a:ln>
+                  <a:noFill/>
+                </a:ln>
+                <a:solidFill>
+                  <a:srgbClr val="006400"/>
+                </a:solidFill>
+                <a:effectLst/>
+                <a:uLnTx/>
+                <a:uFillTx/>
+                <a:latin typeface="Calibri" panose="020F0502020204030204"/>
+                <a:ea typeface="+mn-ea"/>
+                <a:cs typeface="+mn-cs"/>
+              </a:rPr>
+              <a:t>Fast </a:t>
+            </a:r>
+            <a:endParaRPr kumimoji="0" lang="en-US" sz="1000" b="0" i="0" u="none" strike="noStrike" kern="1200" cap="none" spc="0" normalizeH="0" baseline="0" noProof="0" dirty="0">
+              <a:ln>
+                <a:noFill/>
+              </a:ln>
+              <a:solidFill>
+                <a:prstClr val="black"/>
+              </a:solidFill>
+              <a:effectLst/>
+              <a:uLnTx/>
+              <a:uFillTx/>
+              <a:latin typeface="Calibri" panose="020F0502020204030204"/>
+              <a:ea typeface="+mn-ea"/>
+              <a:cs typeface="+mn-cs"/>
+            </a:endParaRPr>
+          </a:p>
+        </p:txBody>
+      </p:sp>
+      <p:sp>
+        <p:nvSpPr>
+          <p:cNvPr id="23" name="Shape 21"/>
+          <p:cNvSpPr/>
+          <p:nvPr/>
+        </p:nvSpPr>
+        <p:spPr>
+          <a:xfrm>
+            <a:off x="274320" y="2532888"/>
+            <a:ext cx="2011680" cy="347472"/>
+          </a:xfrm>
+          <a:prstGeom prst="rect">
+            <a:avLst/>
+          </a:prstGeom>
+          <a:solidFill>
+            <a:srgbClr val="FFFFFF"/>
+          </a:solidFill>
+          <a:ln/>
+        </p:spPr>
+      </p:sp>
+      <p:sp>
+        <p:nvSpPr>
+          <p:cNvPr id="24" name="Text 22"/>
+          <p:cNvSpPr/>
+          <p:nvPr/>
+        </p:nvSpPr>
+        <p:spPr>
+          <a:xfrm>
+            <a:off x="320040" y="2578608"/>
+            <a:ext cx="1920240" cy="256032"/>
+          </a:xfrm>
+          <a:prstGeom prst="rect">
+            <a:avLst/>
+          </a:prstGeom>
+          <a:noFill/>
+          <a:ln/>
+        </p:spPr>
+        <p:txBody>
+          <a:bodyPr wrap="square" lIns="0" tIns="0" rIns="0" bIns="0" rtlCol="0" anchor="ctr"/>
+          <a:lstStyle/>
+          <a:p>
+            <a:pPr marL="0" marR="0" lvl="0" indent="0" algn="l" defTabSz="914400" rtl="0" eaLnBrk="1" fontAlgn="auto" latinLnBrk="0" hangingPunct="1">
+              <a:lnSpc>
+                <a:spcPct val="100000"/>
+              </a:lnSpc>
+              <a:spcBef>
+                <a:spcPts val="0"/>
+              </a:spcBef>
+              <a:spcAft>
+                <a:spcPts val="0"/>
+              </a:spcAft>
+              <a:buClrTx/>
+              <a:buSzTx/>
+              <a:buFontTx/>
+              <a:buNone/>
+              <a:tabLst/>
+              <a:defRPr/>
+            </a:pPr>
+            <a:r>
+              <a:rPr kumimoji="0" lang="en-US" sz="1000" b="0" i="0" u="none" strike="noStrike" kern="1200" cap="none" spc="0" normalizeH="0" baseline="0" noProof="0" dirty="0">
+                <a:ln>
+                  <a:noFill/>
+                </a:ln>
+                <a:solidFill>
+                  <a:srgbClr val="0F1F3D"/>
+                </a:solidFill>
+                <a:effectLst/>
+                <a:uLnTx/>
+                <a:uFillTx/>
+                <a:latin typeface="Calibri" panose="020F0502020204030204"/>
+                <a:ea typeface="+mn-ea"/>
+                <a:cs typeface="+mn-cs"/>
+              </a:rPr>
+              <a:t>Explainability</a:t>
+            </a:r>
+            <a:endParaRPr kumimoji="0" lang="en-US" sz="1000" b="0" i="0" u="none" strike="noStrike" kern="1200" cap="none" spc="0" normalizeH="0" baseline="0" noProof="0" dirty="0">
+              <a:ln>
+                <a:noFill/>
+              </a:ln>
+              <a:solidFill>
+                <a:prstClr val="black"/>
+              </a:solidFill>
+              <a:effectLst/>
+              <a:uLnTx/>
+              <a:uFillTx/>
+              <a:latin typeface="Calibri" panose="020F0502020204030204"/>
+              <a:ea typeface="+mn-ea"/>
+              <a:cs typeface="+mn-cs"/>
+            </a:endParaRPr>
+          </a:p>
+        </p:txBody>
+      </p:sp>
+      <p:sp>
+        <p:nvSpPr>
+          <p:cNvPr id="25" name="Shape 23"/>
+          <p:cNvSpPr/>
+          <p:nvPr/>
+        </p:nvSpPr>
+        <p:spPr>
+          <a:xfrm>
+            <a:off x="2286000" y="2532888"/>
+            <a:ext cx="2011680" cy="347472"/>
+          </a:xfrm>
+          <a:prstGeom prst="rect">
+            <a:avLst/>
+          </a:prstGeom>
+          <a:solidFill>
+            <a:srgbClr val="FFFFFF"/>
+          </a:solidFill>
+          <a:ln/>
+        </p:spPr>
+      </p:sp>
+      <p:sp>
+        <p:nvSpPr>
+          <p:cNvPr id="26" name="Text 24"/>
+          <p:cNvSpPr/>
+          <p:nvPr/>
+        </p:nvSpPr>
+        <p:spPr>
+          <a:xfrm>
+            <a:off x="2331720" y="2578608"/>
+            <a:ext cx="1920240" cy="256032"/>
+          </a:xfrm>
+          <a:prstGeom prst="rect">
+            <a:avLst/>
+          </a:prstGeom>
+          <a:noFill/>
+          <a:ln/>
+        </p:spPr>
+        <p:txBody>
+          <a:bodyPr wrap="square" lIns="0" tIns="0" rIns="0" bIns="0" rtlCol="0" anchor="ctr"/>
+          <a:lstStyle/>
+          <a:p>
+            <a:pPr marL="0" marR="0" lvl="0" indent="0" algn="ctr" defTabSz="914400" rtl="0" eaLnBrk="1" fontAlgn="auto" latinLnBrk="0" hangingPunct="1">
+              <a:lnSpc>
+                <a:spcPct val="100000"/>
+              </a:lnSpc>
+              <a:spcBef>
+                <a:spcPts val="0"/>
+              </a:spcBef>
+              <a:spcAft>
+                <a:spcPts val="0"/>
+              </a:spcAft>
+              <a:buClrTx/>
+              <a:buSzTx/>
+              <a:buFontTx/>
+              <a:buNone/>
+              <a:tabLst/>
+              <a:defRPr/>
+            </a:pPr>
+            <a:r>
+              <a:rPr kumimoji="0" lang="en-US" sz="1000" b="1" i="0" u="none" strike="noStrike" kern="1200" cap="none" spc="0" normalizeH="0" baseline="0" noProof="0" dirty="0">
+                <a:ln>
+                  <a:noFill/>
+                </a:ln>
+                <a:solidFill>
+                  <a:srgbClr val="4A0000"/>
+                </a:solidFill>
+                <a:effectLst/>
+                <a:uLnTx/>
+                <a:uFillTx/>
+                <a:latin typeface="Calibri" panose="020F0502020204030204"/>
+                <a:ea typeface="+mn-ea"/>
+                <a:cs typeface="+mn-cs"/>
+              </a:rPr>
+              <a:t>Low </a:t>
+            </a:r>
+            <a:endParaRPr kumimoji="0" lang="en-US" sz="1000" b="0" i="0" u="none" strike="noStrike" kern="1200" cap="none" spc="0" normalizeH="0" baseline="0" noProof="0" dirty="0">
+              <a:ln>
+                <a:noFill/>
+              </a:ln>
+              <a:solidFill>
+                <a:prstClr val="black"/>
+              </a:solidFill>
+              <a:effectLst/>
+              <a:uLnTx/>
+              <a:uFillTx/>
+              <a:latin typeface="Calibri" panose="020F0502020204030204"/>
+              <a:ea typeface="+mn-ea"/>
+              <a:cs typeface="+mn-cs"/>
+            </a:endParaRPr>
+          </a:p>
+        </p:txBody>
+      </p:sp>
+      <p:sp>
+        <p:nvSpPr>
+          <p:cNvPr id="27" name="Shape 25"/>
+          <p:cNvSpPr/>
+          <p:nvPr/>
+        </p:nvSpPr>
+        <p:spPr>
+          <a:xfrm>
+            <a:off x="4297680" y="2532888"/>
+            <a:ext cx="2011680" cy="347472"/>
+          </a:xfrm>
+          <a:prstGeom prst="rect">
+            <a:avLst/>
+          </a:prstGeom>
+          <a:solidFill>
+            <a:srgbClr val="FFFFFF"/>
+          </a:solidFill>
+          <a:ln/>
+        </p:spPr>
+      </p:sp>
+      <p:sp>
+        <p:nvSpPr>
+          <p:cNvPr id="28" name="Text 26"/>
+          <p:cNvSpPr/>
+          <p:nvPr/>
+        </p:nvSpPr>
+        <p:spPr>
+          <a:xfrm>
+            <a:off x="4343400" y="2578608"/>
+            <a:ext cx="1920240" cy="256032"/>
+          </a:xfrm>
+          <a:prstGeom prst="rect">
+            <a:avLst/>
+          </a:prstGeom>
+          <a:noFill/>
+          <a:ln/>
+        </p:spPr>
+        <p:txBody>
+          <a:bodyPr wrap="square" lIns="0" tIns="0" rIns="0" bIns="0" rtlCol="0" anchor="ctr"/>
+          <a:lstStyle/>
+          <a:p>
+            <a:pPr marL="0" marR="0" lvl="0" indent="0" algn="ctr" defTabSz="914400" rtl="0" eaLnBrk="1" fontAlgn="auto" latinLnBrk="0" hangingPunct="1">
+              <a:lnSpc>
+                <a:spcPct val="100000"/>
+              </a:lnSpc>
+              <a:spcBef>
+                <a:spcPts val="0"/>
+              </a:spcBef>
+              <a:spcAft>
+                <a:spcPts val="0"/>
+              </a:spcAft>
+              <a:buClrTx/>
+              <a:buSzTx/>
+              <a:buFontTx/>
+              <a:buNone/>
+              <a:tabLst/>
+              <a:defRPr/>
+            </a:pPr>
+            <a:r>
+              <a:rPr kumimoji="0" lang="en-US" sz="1000" b="1" i="0" u="none" strike="noStrike" kern="1200" cap="none" spc="0" normalizeH="0" baseline="0" noProof="0" dirty="0">
+                <a:ln>
+                  <a:noFill/>
+                </a:ln>
+                <a:solidFill>
+                  <a:srgbClr val="006400"/>
+                </a:solidFill>
+                <a:effectLst/>
+                <a:uLnTx/>
+                <a:uFillTx/>
+                <a:latin typeface="Calibri" panose="020F0502020204030204"/>
+                <a:ea typeface="+mn-ea"/>
+                <a:cs typeface="+mn-cs"/>
+              </a:rPr>
+              <a:t>High </a:t>
+            </a:r>
+            <a:endParaRPr kumimoji="0" lang="en-US" sz="1000" b="0" i="0" u="none" strike="noStrike" kern="1200" cap="none" spc="0" normalizeH="0" baseline="0" noProof="0" dirty="0">
+              <a:ln>
+                <a:noFill/>
+              </a:ln>
+              <a:solidFill>
+                <a:prstClr val="black"/>
+              </a:solidFill>
+              <a:effectLst/>
+              <a:uLnTx/>
+              <a:uFillTx/>
+              <a:latin typeface="Calibri" panose="020F0502020204030204"/>
+              <a:ea typeface="+mn-ea"/>
+              <a:cs typeface="+mn-cs"/>
+            </a:endParaRPr>
+          </a:p>
+        </p:txBody>
+      </p:sp>
+      <p:sp>
+        <p:nvSpPr>
+          <p:cNvPr id="29" name="Shape 27"/>
+          <p:cNvSpPr/>
+          <p:nvPr/>
+        </p:nvSpPr>
+        <p:spPr>
+          <a:xfrm>
+            <a:off x="274320" y="2916936"/>
+            <a:ext cx="2011680" cy="347472"/>
+          </a:xfrm>
+          <a:prstGeom prst="rect">
+            <a:avLst/>
+          </a:prstGeom>
+          <a:solidFill>
+            <a:srgbClr val="F8F9FA"/>
+          </a:solidFill>
+          <a:ln/>
+        </p:spPr>
+      </p:sp>
+      <p:sp>
+        <p:nvSpPr>
+          <p:cNvPr id="30" name="Text 28"/>
+          <p:cNvSpPr/>
+          <p:nvPr/>
+        </p:nvSpPr>
+        <p:spPr>
+          <a:xfrm>
+            <a:off x="320040" y="2962656"/>
+            <a:ext cx="1920240" cy="256032"/>
+          </a:xfrm>
+          <a:prstGeom prst="rect">
+            <a:avLst/>
+          </a:prstGeom>
+          <a:noFill/>
+          <a:ln/>
+        </p:spPr>
+        <p:txBody>
+          <a:bodyPr wrap="square" lIns="0" tIns="0" rIns="0" bIns="0" rtlCol="0" anchor="ctr"/>
+          <a:lstStyle/>
+          <a:p>
+            <a:pPr marL="0" marR="0" lvl="0" indent="0" algn="l" defTabSz="914400" rtl="0" eaLnBrk="1" fontAlgn="auto" latinLnBrk="0" hangingPunct="1">
+              <a:lnSpc>
+                <a:spcPct val="100000"/>
+              </a:lnSpc>
+              <a:spcBef>
+                <a:spcPts val="0"/>
+              </a:spcBef>
+              <a:spcAft>
+                <a:spcPts val="0"/>
+              </a:spcAft>
+              <a:buClrTx/>
+              <a:buSzTx/>
+              <a:buFontTx/>
+              <a:buNone/>
+              <a:tabLst/>
+              <a:defRPr/>
+            </a:pPr>
+            <a:r>
+              <a:rPr kumimoji="0" lang="en-US" sz="1000" b="0" i="0" u="none" strike="noStrike" kern="1200" cap="none" spc="0" normalizeH="0" baseline="0" noProof="0" dirty="0">
+                <a:ln>
+                  <a:noFill/>
+                </a:ln>
+                <a:solidFill>
+                  <a:srgbClr val="0F1F3D"/>
+                </a:solidFill>
+                <a:effectLst/>
+                <a:uLnTx/>
+                <a:uFillTx/>
+                <a:latin typeface="Calibri" panose="020F0502020204030204"/>
+                <a:ea typeface="+mn-ea"/>
+                <a:cs typeface="+mn-cs"/>
+              </a:rPr>
+              <a:t>Parsimony</a:t>
+            </a:r>
+            <a:endParaRPr kumimoji="0" lang="en-US" sz="1000" b="0" i="0" u="none" strike="noStrike" kern="1200" cap="none" spc="0" normalizeH="0" baseline="0" noProof="0" dirty="0">
+              <a:ln>
+                <a:noFill/>
+              </a:ln>
+              <a:solidFill>
+                <a:prstClr val="black"/>
+              </a:solidFill>
+              <a:effectLst/>
+              <a:uLnTx/>
+              <a:uFillTx/>
+              <a:latin typeface="Calibri" panose="020F0502020204030204"/>
+              <a:ea typeface="+mn-ea"/>
+              <a:cs typeface="+mn-cs"/>
+            </a:endParaRPr>
+          </a:p>
+        </p:txBody>
+      </p:sp>
+      <p:sp>
+        <p:nvSpPr>
+          <p:cNvPr id="31" name="Shape 29"/>
+          <p:cNvSpPr/>
+          <p:nvPr/>
+        </p:nvSpPr>
+        <p:spPr>
+          <a:xfrm>
+            <a:off x="2286000" y="2916936"/>
+            <a:ext cx="2011680" cy="347472"/>
+          </a:xfrm>
+          <a:prstGeom prst="rect">
+            <a:avLst/>
+          </a:prstGeom>
+          <a:solidFill>
+            <a:srgbClr val="F8F9FA"/>
+          </a:solidFill>
+          <a:ln/>
+        </p:spPr>
+      </p:sp>
+      <p:sp>
+        <p:nvSpPr>
+          <p:cNvPr id="32" name="Text 30"/>
+          <p:cNvSpPr/>
+          <p:nvPr/>
+        </p:nvSpPr>
+        <p:spPr>
+          <a:xfrm>
+            <a:off x="2331720" y="2962656"/>
+            <a:ext cx="1920240" cy="256032"/>
+          </a:xfrm>
+          <a:prstGeom prst="rect">
+            <a:avLst/>
+          </a:prstGeom>
+          <a:noFill/>
+          <a:ln/>
+        </p:spPr>
+        <p:txBody>
+          <a:bodyPr wrap="square" lIns="0" tIns="0" rIns="0" bIns="0" rtlCol="0" anchor="ctr"/>
+          <a:lstStyle/>
+          <a:p>
+            <a:pPr marL="0" marR="0" lvl="0" indent="0" algn="ctr" defTabSz="914400" rtl="0" eaLnBrk="1" fontAlgn="auto" latinLnBrk="0" hangingPunct="1">
+              <a:lnSpc>
+                <a:spcPct val="100000"/>
+              </a:lnSpc>
+              <a:spcBef>
+                <a:spcPts val="0"/>
+              </a:spcBef>
+              <a:spcAft>
+                <a:spcPts val="0"/>
+              </a:spcAft>
+              <a:buClrTx/>
+              <a:buSzTx/>
+              <a:buFontTx/>
+              <a:buNone/>
+              <a:tabLst/>
+              <a:defRPr/>
+            </a:pPr>
+            <a:r>
+              <a:rPr kumimoji="0" lang="en-US" sz="1000" b="1" i="0" u="none" strike="noStrike" kern="1200" cap="none" spc="0" normalizeH="0" baseline="0" noProof="0" dirty="0">
+                <a:ln>
+                  <a:noFill/>
+                </a:ln>
+                <a:solidFill>
+                  <a:srgbClr val="4A0000"/>
+                </a:solidFill>
+                <a:effectLst/>
+                <a:uLnTx/>
+                <a:uFillTx/>
+                <a:latin typeface="Calibri" panose="020F0502020204030204"/>
+                <a:ea typeface="+mn-ea"/>
+                <a:cs typeface="+mn-cs"/>
+              </a:rPr>
+              <a:t>Low </a:t>
+            </a:r>
+            <a:endParaRPr kumimoji="0" lang="en-US" sz="1000" b="0" i="0" u="none" strike="noStrike" kern="1200" cap="none" spc="0" normalizeH="0" baseline="0" noProof="0" dirty="0">
+              <a:ln>
+                <a:noFill/>
+              </a:ln>
+              <a:solidFill>
+                <a:prstClr val="black"/>
+              </a:solidFill>
+              <a:effectLst/>
+              <a:uLnTx/>
+              <a:uFillTx/>
+              <a:latin typeface="Calibri" panose="020F0502020204030204"/>
+              <a:ea typeface="+mn-ea"/>
+              <a:cs typeface="+mn-cs"/>
+            </a:endParaRPr>
+          </a:p>
+        </p:txBody>
+      </p:sp>
+      <p:sp>
+        <p:nvSpPr>
+          <p:cNvPr id="33" name="Shape 31"/>
+          <p:cNvSpPr/>
+          <p:nvPr/>
+        </p:nvSpPr>
+        <p:spPr>
+          <a:xfrm>
+            <a:off x="4297680" y="2916936"/>
+            <a:ext cx="2011680" cy="347472"/>
+          </a:xfrm>
+          <a:prstGeom prst="rect">
+            <a:avLst/>
+          </a:prstGeom>
+          <a:solidFill>
+            <a:srgbClr val="F8F9FA"/>
+          </a:solidFill>
+          <a:ln/>
+        </p:spPr>
+      </p:sp>
+      <p:sp>
+        <p:nvSpPr>
+          <p:cNvPr id="34" name="Text 32"/>
+          <p:cNvSpPr/>
+          <p:nvPr/>
+        </p:nvSpPr>
+        <p:spPr>
+          <a:xfrm>
+            <a:off x="4343400" y="2962656"/>
+            <a:ext cx="1920240" cy="256032"/>
+          </a:xfrm>
+          <a:prstGeom prst="rect">
+            <a:avLst/>
+          </a:prstGeom>
+          <a:noFill/>
+          <a:ln/>
+        </p:spPr>
+        <p:txBody>
+          <a:bodyPr wrap="square" lIns="0" tIns="0" rIns="0" bIns="0" rtlCol="0" anchor="ctr"/>
+          <a:lstStyle/>
+          <a:p>
+            <a:pPr marL="0" marR="0" lvl="0" indent="0" algn="ctr" defTabSz="914400" rtl="0" eaLnBrk="1" fontAlgn="auto" latinLnBrk="0" hangingPunct="1">
+              <a:lnSpc>
+                <a:spcPct val="100000"/>
+              </a:lnSpc>
+              <a:spcBef>
+                <a:spcPts val="0"/>
+              </a:spcBef>
+              <a:spcAft>
+                <a:spcPts val="0"/>
+              </a:spcAft>
+              <a:buClrTx/>
+              <a:buSzTx/>
+              <a:buFontTx/>
+              <a:buNone/>
+              <a:tabLst/>
+              <a:defRPr/>
+            </a:pPr>
+            <a:r>
+              <a:rPr kumimoji="0" lang="en-US" sz="1000" b="1" i="0" u="none" strike="noStrike" kern="1200" cap="none" spc="0" normalizeH="0" baseline="0" noProof="0" dirty="0">
+                <a:ln>
+                  <a:noFill/>
+                </a:ln>
+                <a:solidFill>
+                  <a:srgbClr val="006400"/>
+                </a:solidFill>
+                <a:effectLst/>
+                <a:uLnTx/>
+                <a:uFillTx/>
+                <a:latin typeface="Calibri" panose="020F0502020204030204"/>
+                <a:ea typeface="+mn-ea"/>
+                <a:cs typeface="+mn-cs"/>
+              </a:rPr>
+              <a:t>High </a:t>
+            </a:r>
+            <a:endParaRPr kumimoji="0" lang="en-US" sz="1000" b="0" i="0" u="none" strike="noStrike" kern="1200" cap="none" spc="0" normalizeH="0" baseline="0" noProof="0" dirty="0">
+              <a:ln>
+                <a:noFill/>
+              </a:ln>
+              <a:solidFill>
+                <a:prstClr val="black"/>
+              </a:solidFill>
+              <a:effectLst/>
+              <a:uLnTx/>
+              <a:uFillTx/>
+              <a:latin typeface="Calibri" panose="020F0502020204030204"/>
+              <a:ea typeface="+mn-ea"/>
+              <a:cs typeface="+mn-cs"/>
+            </a:endParaRPr>
+          </a:p>
+        </p:txBody>
+      </p:sp>
+      <p:sp>
+        <p:nvSpPr>
+          <p:cNvPr id="35" name="Shape 33"/>
+          <p:cNvSpPr/>
+          <p:nvPr/>
+        </p:nvSpPr>
+        <p:spPr>
+          <a:xfrm>
+            <a:off x="274320" y="3300984"/>
+            <a:ext cx="2011680" cy="347472"/>
+          </a:xfrm>
+          <a:prstGeom prst="rect">
+            <a:avLst/>
+          </a:prstGeom>
+          <a:solidFill>
+            <a:srgbClr val="FFFFFF"/>
+          </a:solidFill>
+          <a:ln/>
+        </p:spPr>
+      </p:sp>
+      <p:sp>
+        <p:nvSpPr>
+          <p:cNvPr id="36" name="Text 34"/>
+          <p:cNvSpPr/>
+          <p:nvPr/>
+        </p:nvSpPr>
+        <p:spPr>
+          <a:xfrm>
+            <a:off x="320040" y="3346704"/>
+            <a:ext cx="1920240" cy="256032"/>
+          </a:xfrm>
+          <a:prstGeom prst="rect">
+            <a:avLst/>
+          </a:prstGeom>
+          <a:noFill/>
+          <a:ln/>
+        </p:spPr>
+        <p:txBody>
+          <a:bodyPr wrap="square" lIns="0" tIns="0" rIns="0" bIns="0" rtlCol="0" anchor="ctr"/>
+          <a:lstStyle/>
+          <a:p>
+            <a:pPr marL="0" marR="0" lvl="0" indent="0" algn="l" defTabSz="914400" rtl="0" eaLnBrk="1" fontAlgn="auto" latinLnBrk="0" hangingPunct="1">
+              <a:lnSpc>
+                <a:spcPct val="100000"/>
+              </a:lnSpc>
+              <a:spcBef>
+                <a:spcPts val="0"/>
+              </a:spcBef>
+              <a:spcAft>
+                <a:spcPts val="0"/>
+              </a:spcAft>
+              <a:buClrTx/>
+              <a:buSzTx/>
+              <a:buFontTx/>
+              <a:buNone/>
+              <a:tabLst/>
+              <a:defRPr/>
+            </a:pPr>
+            <a:r>
+              <a:rPr kumimoji="0" lang="en-US" sz="1000" b="0" i="0" u="none" strike="noStrike" kern="1200" cap="none" spc="0" normalizeH="0" baseline="0" noProof="0" dirty="0">
+                <a:ln>
+                  <a:noFill/>
+                </a:ln>
+                <a:solidFill>
+                  <a:srgbClr val="0F1F3D"/>
+                </a:solidFill>
+                <a:effectLst/>
+                <a:uLnTx/>
+                <a:uFillTx/>
+                <a:latin typeface="Calibri" panose="020F0502020204030204"/>
+                <a:ea typeface="+mn-ea"/>
+                <a:cs typeface="+mn-cs"/>
+              </a:rPr>
+              <a:t>Ease of Deployment</a:t>
+            </a:r>
+            <a:endParaRPr kumimoji="0" lang="en-US" sz="1000" b="0" i="0" u="none" strike="noStrike" kern="1200" cap="none" spc="0" normalizeH="0" baseline="0" noProof="0" dirty="0">
+              <a:ln>
+                <a:noFill/>
+              </a:ln>
+              <a:solidFill>
+                <a:prstClr val="black"/>
+              </a:solidFill>
+              <a:effectLst/>
+              <a:uLnTx/>
+              <a:uFillTx/>
+              <a:latin typeface="Calibri" panose="020F0502020204030204"/>
+              <a:ea typeface="+mn-ea"/>
+              <a:cs typeface="+mn-cs"/>
+            </a:endParaRPr>
+          </a:p>
+        </p:txBody>
+      </p:sp>
+      <p:sp>
+        <p:nvSpPr>
+          <p:cNvPr id="37" name="Shape 35"/>
+          <p:cNvSpPr/>
+          <p:nvPr/>
+        </p:nvSpPr>
+        <p:spPr>
+          <a:xfrm>
+            <a:off x="2286000" y="3300984"/>
+            <a:ext cx="2011680" cy="347472"/>
+          </a:xfrm>
+          <a:prstGeom prst="rect">
+            <a:avLst/>
+          </a:prstGeom>
+          <a:solidFill>
+            <a:srgbClr val="FFFFFF"/>
+          </a:solidFill>
+          <a:ln/>
+        </p:spPr>
+      </p:sp>
+      <p:sp>
+        <p:nvSpPr>
+          <p:cNvPr id="38" name="Text 36"/>
+          <p:cNvSpPr/>
+          <p:nvPr/>
+        </p:nvSpPr>
+        <p:spPr>
+          <a:xfrm>
+            <a:off x="2331720" y="3346704"/>
+            <a:ext cx="1920240" cy="256032"/>
+          </a:xfrm>
+          <a:prstGeom prst="rect">
+            <a:avLst/>
+          </a:prstGeom>
+          <a:noFill/>
+          <a:ln/>
+        </p:spPr>
+        <p:txBody>
+          <a:bodyPr wrap="square" lIns="0" tIns="0" rIns="0" bIns="0" rtlCol="0" anchor="ctr"/>
+          <a:lstStyle/>
+          <a:p>
+            <a:pPr marL="0" marR="0" lvl="0" indent="0" algn="ctr" defTabSz="914400" rtl="0" eaLnBrk="1" fontAlgn="auto" latinLnBrk="0" hangingPunct="1">
+              <a:lnSpc>
+                <a:spcPct val="100000"/>
+              </a:lnSpc>
+              <a:spcBef>
+                <a:spcPts val="0"/>
+              </a:spcBef>
+              <a:spcAft>
+                <a:spcPts val="0"/>
+              </a:spcAft>
+              <a:buClrTx/>
+              <a:buSzTx/>
+              <a:buFontTx/>
+              <a:buNone/>
+              <a:tabLst/>
+              <a:defRPr/>
+            </a:pPr>
+            <a:r>
+              <a:rPr kumimoji="0" lang="en-US" sz="1000" b="1" i="0" u="none" strike="noStrike" kern="1200" cap="none" spc="0" normalizeH="0" baseline="0" noProof="0" dirty="0">
+                <a:ln>
+                  <a:noFill/>
+                </a:ln>
+                <a:solidFill>
+                  <a:srgbClr val="4A0000"/>
+                </a:solidFill>
+                <a:effectLst/>
+                <a:uLnTx/>
+                <a:uFillTx/>
+                <a:latin typeface="Calibri" panose="020F0502020204030204"/>
+                <a:ea typeface="+mn-ea"/>
+                <a:cs typeface="+mn-cs"/>
+              </a:rPr>
+              <a:t>Complex </a:t>
+            </a:r>
+            <a:endParaRPr kumimoji="0" lang="en-US" sz="1000" b="0" i="0" u="none" strike="noStrike" kern="1200" cap="none" spc="0" normalizeH="0" baseline="0" noProof="0" dirty="0">
+              <a:ln>
+                <a:noFill/>
+              </a:ln>
+              <a:solidFill>
+                <a:prstClr val="black"/>
+              </a:solidFill>
+              <a:effectLst/>
+              <a:uLnTx/>
+              <a:uFillTx/>
+              <a:latin typeface="Calibri" panose="020F0502020204030204"/>
+              <a:ea typeface="+mn-ea"/>
+              <a:cs typeface="+mn-cs"/>
+            </a:endParaRPr>
+          </a:p>
+        </p:txBody>
+      </p:sp>
+      <p:sp>
+        <p:nvSpPr>
+          <p:cNvPr id="39" name="Shape 37"/>
+          <p:cNvSpPr/>
+          <p:nvPr/>
+        </p:nvSpPr>
+        <p:spPr>
+          <a:xfrm>
+            <a:off x="4297680" y="3300984"/>
+            <a:ext cx="2011680" cy="347472"/>
+          </a:xfrm>
+          <a:prstGeom prst="rect">
+            <a:avLst/>
+          </a:prstGeom>
+          <a:solidFill>
+            <a:srgbClr val="FFFFFF"/>
+          </a:solidFill>
+          <a:ln/>
+        </p:spPr>
+      </p:sp>
+      <p:sp>
+        <p:nvSpPr>
+          <p:cNvPr id="40" name="Text 38"/>
+          <p:cNvSpPr/>
+          <p:nvPr/>
+        </p:nvSpPr>
+        <p:spPr>
+          <a:xfrm>
+            <a:off x="4343400" y="3346704"/>
+            <a:ext cx="1920240" cy="256032"/>
+          </a:xfrm>
+          <a:prstGeom prst="rect">
+            <a:avLst/>
+          </a:prstGeom>
+          <a:noFill/>
+          <a:ln/>
+        </p:spPr>
+        <p:txBody>
+          <a:bodyPr wrap="square" lIns="0" tIns="0" rIns="0" bIns="0" rtlCol="0" anchor="ctr"/>
+          <a:lstStyle/>
+          <a:p>
+            <a:pPr marL="0" marR="0" lvl="0" indent="0" algn="ctr" defTabSz="914400" rtl="0" eaLnBrk="1" fontAlgn="auto" latinLnBrk="0" hangingPunct="1">
+              <a:lnSpc>
+                <a:spcPct val="100000"/>
+              </a:lnSpc>
+              <a:spcBef>
+                <a:spcPts val="0"/>
+              </a:spcBef>
+              <a:spcAft>
+                <a:spcPts val="0"/>
+              </a:spcAft>
+              <a:buClrTx/>
+              <a:buSzTx/>
+              <a:buFontTx/>
+              <a:buNone/>
+              <a:tabLst/>
+              <a:defRPr/>
+            </a:pPr>
+            <a:r>
+              <a:rPr kumimoji="0" lang="en-US" sz="1000" b="1" i="0" u="none" strike="noStrike" kern="1200" cap="none" spc="0" normalizeH="0" baseline="0" noProof="0" dirty="0">
+                <a:ln>
+                  <a:noFill/>
+                </a:ln>
+                <a:solidFill>
+                  <a:srgbClr val="006400"/>
+                </a:solidFill>
+                <a:effectLst/>
+                <a:uLnTx/>
+                <a:uFillTx/>
+                <a:latin typeface="Calibri" panose="020F0502020204030204"/>
+                <a:ea typeface="+mn-ea"/>
+                <a:cs typeface="+mn-cs"/>
+              </a:rPr>
+              <a:t>Simple </a:t>
+            </a:r>
+            <a:endParaRPr kumimoji="0" lang="en-US" sz="1000" b="0" i="0" u="none" strike="noStrike" kern="1200" cap="none" spc="0" normalizeH="0" baseline="0" noProof="0" dirty="0">
+              <a:ln>
+                <a:noFill/>
+              </a:ln>
+              <a:solidFill>
+                <a:prstClr val="black"/>
+              </a:solidFill>
+              <a:effectLst/>
+              <a:uLnTx/>
+              <a:uFillTx/>
+              <a:latin typeface="Calibri" panose="020F0502020204030204"/>
+              <a:ea typeface="+mn-ea"/>
+              <a:cs typeface="+mn-cs"/>
+            </a:endParaRPr>
+          </a:p>
+        </p:txBody>
+      </p:sp>
+      <p:sp>
+        <p:nvSpPr>
+          <p:cNvPr id="41" name="Shape 39"/>
+          <p:cNvSpPr/>
+          <p:nvPr/>
+        </p:nvSpPr>
+        <p:spPr>
+          <a:xfrm>
+            <a:off x="6400800" y="1417320"/>
+            <a:ext cx="2468880" cy="2304288"/>
+          </a:xfrm>
+          <a:prstGeom prst="rect">
+            <a:avLst/>
+          </a:prstGeom>
+          <a:solidFill>
+            <a:srgbClr val="0F1F3D"/>
+          </a:solidFill>
+          <a:ln/>
+          <a:effectLst>
+            <a:outerShdw blurRad="101600" dist="38100" dir="8100000" algn="bl" rotWithShape="0">
+              <a:srgbClr val="000000">
+                <a:alpha val="15000"/>
+              </a:srgbClr>
+            </a:outerShdw>
+          </a:effectLst>
+        </p:spPr>
+      </p:sp>
+      <p:sp>
+        <p:nvSpPr>
+          <p:cNvPr id="42" name="Text 40"/>
+          <p:cNvSpPr/>
+          <p:nvPr/>
+        </p:nvSpPr>
+        <p:spPr>
+          <a:xfrm>
+            <a:off x="6400800" y="1508760"/>
+            <a:ext cx="2468880" cy="320040"/>
+          </a:xfrm>
+          <a:prstGeom prst="rect">
+            <a:avLst/>
+          </a:prstGeom>
+          <a:noFill/>
+          <a:ln/>
+        </p:spPr>
+        <p:txBody>
+          <a:bodyPr wrap="square" rtlCol="0" anchor="ctr"/>
+          <a:lstStyle/>
+          <a:p>
+            <a:pPr marL="0" marR="0" lvl="0" indent="0" algn="ctr" defTabSz="914400" rtl="0" eaLnBrk="1" fontAlgn="auto" latinLnBrk="0" hangingPunct="1">
+              <a:lnSpc>
+                <a:spcPct val="100000"/>
+              </a:lnSpc>
+              <a:spcBef>
+                <a:spcPts val="0"/>
+              </a:spcBef>
+              <a:spcAft>
+                <a:spcPts val="0"/>
+              </a:spcAft>
+              <a:buClrTx/>
+              <a:buSzTx/>
+              <a:buFontTx/>
+              <a:buNone/>
+              <a:tabLst/>
+              <a:defRPr/>
+            </a:pPr>
+            <a:r>
+              <a:rPr kumimoji="0" lang="en-US" sz="1100" b="1" i="0" u="none" strike="noStrike" kern="0" cap="none" spc="200" normalizeH="0" baseline="0" noProof="0" dirty="0">
+                <a:ln>
+                  <a:noFill/>
+                </a:ln>
+                <a:solidFill>
+                  <a:srgbClr val="00B4D8"/>
+                </a:solidFill>
+                <a:effectLst/>
+                <a:uLnTx/>
+                <a:uFillTx/>
+                <a:latin typeface="Calibri" panose="020F0502020204030204"/>
+                <a:ea typeface="+mn-ea"/>
+                <a:cs typeface="+mn-cs"/>
+              </a:rPr>
+              <a:t>Key Insight</a:t>
+            </a:r>
+            <a:endParaRPr kumimoji="0" lang="en-US" sz="1100" b="0" i="0" u="none" strike="noStrike" kern="1200" cap="none" spc="0" normalizeH="0" baseline="0" noProof="0" dirty="0">
+              <a:ln>
+                <a:noFill/>
+              </a:ln>
+              <a:solidFill>
+                <a:prstClr val="black"/>
+              </a:solidFill>
+              <a:effectLst/>
+              <a:uLnTx/>
+              <a:uFillTx/>
+              <a:latin typeface="Calibri" panose="020F0502020204030204"/>
+              <a:ea typeface="+mn-ea"/>
+              <a:cs typeface="+mn-cs"/>
+            </a:endParaRPr>
+          </a:p>
+        </p:txBody>
+      </p:sp>
+      <p:sp>
+        <p:nvSpPr>
+          <p:cNvPr id="43" name="Text 41"/>
+          <p:cNvSpPr/>
+          <p:nvPr/>
+        </p:nvSpPr>
+        <p:spPr>
+          <a:xfrm>
+            <a:off x="6492240" y="1920240"/>
+            <a:ext cx="2286000" cy="548640"/>
+          </a:xfrm>
+          <a:prstGeom prst="rect">
+            <a:avLst/>
+          </a:prstGeom>
+          <a:noFill/>
+          <a:ln/>
+        </p:spPr>
+        <p:txBody>
+          <a:bodyPr wrap="square" rtlCol="0" anchor="ctr"/>
+          <a:lstStyle/>
+          <a:p>
+            <a:pPr marL="0" marR="0" lvl="0" indent="0" algn="ctr" defTabSz="914400" rtl="0" eaLnBrk="1" fontAlgn="auto" latinLnBrk="0" hangingPunct="1">
+              <a:lnSpc>
+                <a:spcPct val="120000"/>
+              </a:lnSpc>
+              <a:spcBef>
+                <a:spcPts val="0"/>
+              </a:spcBef>
+              <a:spcAft>
+                <a:spcPts val="0"/>
+              </a:spcAft>
+              <a:buClrTx/>
+              <a:buSzTx/>
+              <a:buFontTx/>
+              <a:buNone/>
+              <a:tabLst/>
+              <a:defRPr/>
+            </a:pPr>
+            <a:r>
+              <a:rPr kumimoji="0" lang="en-US" sz="950" b="0" i="0" u="none" strike="noStrike" kern="1200" cap="none" spc="0" normalizeH="0" baseline="0" noProof="0" dirty="0">
+                <a:ln>
+                  <a:noFill/>
+                </a:ln>
+                <a:solidFill>
+                  <a:srgbClr val="CBD5E1"/>
+                </a:solidFill>
+                <a:effectLst/>
+                <a:uLnTx/>
+                <a:uFillTx/>
+                <a:latin typeface="Calibri" panose="020F0502020204030204"/>
+                <a:ea typeface="+mn-ea"/>
+                <a:cs typeface="+mn-cs"/>
+              </a:rPr>
+              <a:t>ROC AUC difference between Random Forest and Logistic Regression is only</a:t>
+            </a:r>
+            <a:endParaRPr kumimoji="0" lang="en-US" sz="950" b="0" i="0" u="none" strike="noStrike" kern="1200" cap="none" spc="0" normalizeH="0" baseline="0" noProof="0" dirty="0">
+              <a:ln>
+                <a:noFill/>
+              </a:ln>
+              <a:solidFill>
+                <a:prstClr val="black"/>
+              </a:solidFill>
+              <a:effectLst/>
+              <a:uLnTx/>
+              <a:uFillTx/>
+              <a:latin typeface="Calibri" panose="020F0502020204030204"/>
+              <a:ea typeface="+mn-ea"/>
+              <a:cs typeface="+mn-cs"/>
+            </a:endParaRPr>
+          </a:p>
+        </p:txBody>
+      </p:sp>
+      <p:sp>
+        <p:nvSpPr>
+          <p:cNvPr id="44" name="Text 42"/>
+          <p:cNvSpPr/>
+          <p:nvPr/>
+        </p:nvSpPr>
+        <p:spPr>
+          <a:xfrm>
+            <a:off x="6400800" y="2468880"/>
+            <a:ext cx="2468880" cy="457200"/>
+          </a:xfrm>
+          <a:prstGeom prst="rect">
+            <a:avLst/>
+          </a:prstGeom>
+          <a:noFill/>
+          <a:ln/>
+        </p:spPr>
+        <p:txBody>
+          <a:bodyPr wrap="square" rtlCol="0" anchor="ctr"/>
+          <a:lstStyle/>
+          <a:p>
+            <a:pPr marL="0" marR="0" lvl="0" indent="0" algn="ctr" defTabSz="914400" rtl="0" eaLnBrk="1" fontAlgn="auto" latinLnBrk="0" hangingPunct="1">
+              <a:lnSpc>
+                <a:spcPct val="100000"/>
+              </a:lnSpc>
+              <a:spcBef>
+                <a:spcPts val="0"/>
+              </a:spcBef>
+              <a:spcAft>
+                <a:spcPts val="0"/>
+              </a:spcAft>
+              <a:buClrTx/>
+              <a:buSzTx/>
+              <a:buFontTx/>
+              <a:buNone/>
+              <a:tabLst/>
+              <a:defRPr/>
+            </a:pPr>
+            <a:r>
+              <a:rPr kumimoji="0" lang="en-US" sz="2800" b="1" i="0" u="none" strike="noStrike" kern="1200" cap="none" spc="0" normalizeH="0" baseline="0" noProof="0" dirty="0">
+                <a:ln>
+                  <a:noFill/>
+                </a:ln>
+                <a:solidFill>
+                  <a:srgbClr val="00B4D8"/>
+                </a:solidFill>
+                <a:effectLst/>
+                <a:uLnTx/>
+                <a:uFillTx/>
+                <a:latin typeface="Calibri" panose="020F0502020204030204"/>
+                <a:ea typeface="+mn-ea"/>
+                <a:cs typeface="+mn-cs"/>
+              </a:rPr>
+              <a:t>0.0012</a:t>
+            </a:r>
+            <a:endParaRPr kumimoji="0" lang="en-US" sz="2800" b="0" i="0" u="none" strike="noStrike" kern="1200" cap="none" spc="0" normalizeH="0" baseline="0" noProof="0" dirty="0">
+              <a:ln>
+                <a:noFill/>
+              </a:ln>
+              <a:solidFill>
+                <a:prstClr val="black"/>
+              </a:solidFill>
+              <a:effectLst/>
+              <a:uLnTx/>
+              <a:uFillTx/>
+              <a:latin typeface="Calibri" panose="020F0502020204030204"/>
+              <a:ea typeface="+mn-ea"/>
+              <a:cs typeface="+mn-cs"/>
+            </a:endParaRPr>
+          </a:p>
+        </p:txBody>
+      </p:sp>
+      <p:sp>
+        <p:nvSpPr>
+          <p:cNvPr id="45" name="Text 43"/>
+          <p:cNvSpPr/>
+          <p:nvPr/>
+        </p:nvSpPr>
+        <p:spPr>
+          <a:xfrm>
+            <a:off x="6400800" y="2926080"/>
+            <a:ext cx="2468880" cy="274320"/>
+          </a:xfrm>
+          <a:prstGeom prst="rect">
+            <a:avLst/>
+          </a:prstGeom>
+          <a:noFill/>
+          <a:ln/>
+        </p:spPr>
+        <p:txBody>
+          <a:bodyPr wrap="square" rtlCol="0" anchor="ctr"/>
+          <a:lstStyle/>
+          <a:p>
+            <a:pPr marL="0" marR="0" lvl="0" indent="0" algn="ctr" defTabSz="914400" rtl="0" eaLnBrk="1" fontAlgn="auto" latinLnBrk="0" hangingPunct="1">
+              <a:lnSpc>
+                <a:spcPct val="100000"/>
+              </a:lnSpc>
+              <a:spcBef>
+                <a:spcPts val="0"/>
+              </a:spcBef>
+              <a:spcAft>
+                <a:spcPts val="0"/>
+              </a:spcAft>
+              <a:buClrTx/>
+              <a:buSzTx/>
+              <a:buFontTx/>
+              <a:buNone/>
+              <a:tabLst/>
+              <a:defRPr/>
+            </a:pPr>
+            <a:r>
+              <a:rPr kumimoji="0" lang="en-US" sz="900" b="0" i="1" u="none" strike="noStrike" kern="1200" cap="none" spc="0" normalizeH="0" baseline="0" noProof="0" dirty="0">
+                <a:ln>
+                  <a:noFill/>
+                </a:ln>
+                <a:solidFill>
+                  <a:srgbClr val="CBD5E1"/>
+                </a:solidFill>
+                <a:effectLst/>
+                <a:uLnTx/>
+                <a:uFillTx/>
+                <a:latin typeface="Calibri" panose="020F0502020204030204"/>
+                <a:ea typeface="+mn-ea"/>
+                <a:cs typeface="+mn-cs"/>
+              </a:rPr>
+              <a:t>Practically negligible</a:t>
+            </a:r>
+            <a:endParaRPr kumimoji="0" lang="en-US" sz="900" b="0" i="0" u="none" strike="noStrike" kern="1200" cap="none" spc="0" normalizeH="0" baseline="0" noProof="0" dirty="0">
+              <a:ln>
+                <a:noFill/>
+              </a:ln>
+              <a:solidFill>
+                <a:prstClr val="black"/>
+              </a:solidFill>
+              <a:effectLst/>
+              <a:uLnTx/>
+              <a:uFillTx/>
+              <a:latin typeface="Calibri" panose="020F0502020204030204"/>
+              <a:ea typeface="+mn-ea"/>
+              <a:cs typeface="+mn-cs"/>
+            </a:endParaRPr>
+          </a:p>
+        </p:txBody>
+      </p:sp>
+      <p:sp>
+        <p:nvSpPr>
+          <p:cNvPr id="46" name="Shape 44"/>
+          <p:cNvSpPr/>
+          <p:nvPr/>
+        </p:nvSpPr>
+        <p:spPr>
+          <a:xfrm>
+            <a:off x="274320" y="3749040"/>
+            <a:ext cx="6035040" cy="822960"/>
+          </a:xfrm>
+          <a:prstGeom prst="rect">
+            <a:avLst/>
+          </a:prstGeom>
+          <a:solidFill>
+            <a:srgbClr val="FFFFFF"/>
+          </a:solidFill>
+          <a:ln/>
+          <a:effectLst>
+            <a:outerShdw blurRad="101600" dist="38100" dir="8100000" algn="bl" rotWithShape="0">
+              <a:srgbClr val="000000">
+                <a:alpha val="15000"/>
+              </a:srgbClr>
+            </a:outerShdw>
+          </a:effectLst>
+        </p:spPr>
+      </p:sp>
+      <p:sp>
+        <p:nvSpPr>
+          <p:cNvPr id="47" name="Shape 45"/>
+          <p:cNvSpPr/>
+          <p:nvPr/>
+        </p:nvSpPr>
+        <p:spPr>
+          <a:xfrm>
+            <a:off x="274320" y="3749040"/>
+            <a:ext cx="64008" cy="822960"/>
+          </a:xfrm>
+          <a:prstGeom prst="rect">
+            <a:avLst/>
+          </a:prstGeom>
+          <a:solidFill>
+            <a:srgbClr val="006400"/>
+          </a:solidFill>
+          <a:ln/>
+        </p:spPr>
+      </p:sp>
+      <p:sp>
+        <p:nvSpPr>
+          <p:cNvPr id="48" name="Text 46"/>
+          <p:cNvSpPr/>
+          <p:nvPr/>
+        </p:nvSpPr>
+        <p:spPr>
+          <a:xfrm>
+            <a:off x="457200" y="3794760"/>
+            <a:ext cx="5669280" cy="274320"/>
+          </a:xfrm>
+          <a:prstGeom prst="rect">
+            <a:avLst/>
+          </a:prstGeom>
+          <a:noFill/>
+          <a:ln/>
+        </p:spPr>
+        <p:txBody>
+          <a:bodyPr wrap="square" lIns="0" tIns="0" rIns="0" bIns="0" rtlCol="0" anchor="ctr"/>
+          <a:lstStyle/>
+          <a:p>
+            <a:pPr marL="0" marR="0" lvl="0" indent="0" algn="l" defTabSz="914400" rtl="0" eaLnBrk="1" fontAlgn="auto" latinLnBrk="0" hangingPunct="1">
+              <a:lnSpc>
+                <a:spcPct val="100000"/>
+              </a:lnSpc>
+              <a:spcBef>
+                <a:spcPts val="0"/>
+              </a:spcBef>
+              <a:spcAft>
+                <a:spcPts val="0"/>
+              </a:spcAft>
+              <a:buClrTx/>
+              <a:buSzTx/>
+              <a:buFontTx/>
+              <a:buNone/>
+              <a:tabLst/>
+              <a:defRPr/>
+            </a:pPr>
+            <a:r>
+              <a:rPr kumimoji="0" lang="en-US" sz="1100" b="1" i="0" u="none" strike="noStrike" kern="1200" cap="none" spc="0" normalizeH="0" baseline="0" noProof="0" dirty="0">
+                <a:ln>
+                  <a:noFill/>
+                </a:ln>
+                <a:solidFill>
+                  <a:srgbClr val="006400"/>
+                </a:solidFill>
+                <a:effectLst/>
+                <a:uLnTx/>
+                <a:uFillTx/>
+                <a:latin typeface="Calibri" panose="020F0502020204030204"/>
+                <a:ea typeface="+mn-ea"/>
+                <a:cs typeface="+mn-cs"/>
+              </a:rPr>
+              <a:t>✅  No Data Leakage</a:t>
+            </a:r>
+            <a:endParaRPr kumimoji="0" lang="en-US" sz="1100" b="0" i="0" u="none" strike="noStrike" kern="1200" cap="none" spc="0" normalizeH="0" baseline="0" noProof="0" dirty="0">
+              <a:ln>
+                <a:noFill/>
+              </a:ln>
+              <a:solidFill>
+                <a:prstClr val="black"/>
+              </a:solidFill>
+              <a:effectLst/>
+              <a:uLnTx/>
+              <a:uFillTx/>
+              <a:latin typeface="Calibri" panose="020F0502020204030204"/>
+              <a:ea typeface="+mn-ea"/>
+              <a:cs typeface="+mn-cs"/>
+            </a:endParaRPr>
+          </a:p>
+        </p:txBody>
+      </p:sp>
+      <p:sp>
+        <p:nvSpPr>
+          <p:cNvPr id="49" name="Text 47"/>
+          <p:cNvSpPr/>
+          <p:nvPr/>
+        </p:nvSpPr>
+        <p:spPr>
+          <a:xfrm>
+            <a:off x="457200" y="4096512"/>
+            <a:ext cx="5669280" cy="411480"/>
+          </a:xfrm>
+          <a:prstGeom prst="rect">
+            <a:avLst/>
+          </a:prstGeom>
+          <a:noFill/>
+          <a:ln/>
+        </p:spPr>
+        <p:txBody>
+          <a:bodyPr wrap="square" lIns="0" tIns="0" rIns="0" bIns="0" rtlCol="0" anchor="ctr"/>
+          <a:lstStyle/>
+          <a:p>
+            <a:pPr marL="0" marR="0" lvl="0" indent="0" algn="l" defTabSz="914400" rtl="0" eaLnBrk="1" fontAlgn="auto" latinLnBrk="0" hangingPunct="1">
+              <a:lnSpc>
+                <a:spcPct val="120000"/>
+              </a:lnSpc>
+              <a:spcBef>
+                <a:spcPts val="0"/>
+              </a:spcBef>
+              <a:spcAft>
+                <a:spcPts val="0"/>
+              </a:spcAft>
+              <a:buClrTx/>
+              <a:buSzTx/>
+              <a:buFontTx/>
+              <a:buNone/>
+              <a:tabLst/>
+              <a:defRPr/>
+            </a:pPr>
+            <a:r>
+              <a:rPr kumimoji="0" lang="en-US" sz="950" b="0" i="0" u="none" strike="noStrike" kern="1200" cap="none" spc="0" normalizeH="0" baseline="0" noProof="0" dirty="0">
+                <a:ln>
+                  <a:noFill/>
+                </a:ln>
+                <a:solidFill>
+                  <a:srgbClr val="64748B"/>
+                </a:solidFill>
+                <a:effectLst/>
+                <a:uLnTx/>
+                <a:uFillTx/>
+                <a:latin typeface="Calibri" panose="020F0502020204030204"/>
+                <a:ea typeface="+mn-ea"/>
+                <a:cs typeface="+mn-cs"/>
+              </a:rPr>
+              <a:t>All transformers fitted on training data only — imputation, scaling and encoding applied to test set using training statistics exclusively</a:t>
+            </a:r>
+            <a:endParaRPr kumimoji="0" lang="en-US" sz="950" b="0" i="0" u="none" strike="noStrike" kern="1200" cap="none" spc="0" normalizeH="0" baseline="0" noProof="0" dirty="0">
+              <a:ln>
+                <a:noFill/>
+              </a:ln>
+              <a:solidFill>
+                <a:prstClr val="black"/>
+              </a:solidFill>
+              <a:effectLst/>
+              <a:uLnTx/>
+              <a:uFillTx/>
+              <a:latin typeface="Calibri" panose="020F0502020204030204"/>
+              <a:ea typeface="+mn-ea"/>
+              <a:cs typeface="+mn-cs"/>
+            </a:endParaRPr>
+          </a:p>
+        </p:txBody>
+      </p:sp>
+      <p:sp>
+        <p:nvSpPr>
+          <p:cNvPr id="50" name="Shape 48"/>
+          <p:cNvSpPr/>
+          <p:nvPr/>
+        </p:nvSpPr>
+        <p:spPr>
+          <a:xfrm>
+            <a:off x="6400800" y="3749040"/>
+            <a:ext cx="2468880" cy="822960"/>
+          </a:xfrm>
+          <a:prstGeom prst="rect">
+            <a:avLst/>
+          </a:prstGeom>
+          <a:solidFill>
+            <a:schemeClr val="accent1">
+              <a:lumMod val="50000"/>
+            </a:schemeClr>
+          </a:solidFill>
+          <a:ln/>
+          <a:effectLst>
+            <a:outerShdw blurRad="101600" dist="38100" dir="8100000" algn="bl" rotWithShape="0">
+              <a:srgbClr val="000000">
+                <a:alpha val="15000"/>
+              </a:srgbClr>
+            </a:outerShdw>
+          </a:effectLst>
+        </p:spPr>
+      </p:sp>
+      <p:sp>
+        <p:nvSpPr>
+          <p:cNvPr id="51" name="Text 49"/>
+          <p:cNvSpPr/>
+          <p:nvPr/>
+        </p:nvSpPr>
+        <p:spPr>
+          <a:xfrm>
+            <a:off x="6492240" y="3822192"/>
+            <a:ext cx="2286000" cy="676656"/>
+          </a:xfrm>
+          <a:prstGeom prst="rect">
+            <a:avLst/>
+          </a:prstGeom>
+          <a:noFill/>
+          <a:ln/>
+        </p:spPr>
+        <p:txBody>
+          <a:bodyPr wrap="square" rtlCol="0" anchor="ctr"/>
+          <a:lstStyle/>
+          <a:p>
+            <a:pPr marL="0" marR="0" lvl="0" indent="0" algn="ctr" defTabSz="914400" rtl="0" eaLnBrk="1" fontAlgn="auto" latinLnBrk="0" hangingPunct="1">
+              <a:lnSpc>
+                <a:spcPct val="120000"/>
+              </a:lnSpc>
+              <a:spcBef>
+                <a:spcPts val="0"/>
+              </a:spcBef>
+              <a:spcAft>
+                <a:spcPts val="0"/>
+              </a:spcAft>
+              <a:buClrTx/>
+              <a:buSzTx/>
+              <a:buFontTx/>
+              <a:buNone/>
+              <a:tabLst/>
+              <a:defRPr/>
+            </a:pPr>
+            <a:r>
+              <a:rPr kumimoji="0" lang="en-US" sz="850" b="0" i="0" u="none" strike="noStrike" kern="1200" cap="none" spc="0" normalizeH="0" baseline="0" noProof="0" dirty="0">
+                <a:ln>
+                  <a:noFill/>
+                </a:ln>
+                <a:solidFill>
+                  <a:srgbClr val="FFFFFF"/>
+                </a:solidFill>
+                <a:effectLst/>
+                <a:uLnTx/>
+                <a:uFillTx/>
+                <a:latin typeface="Calibri" panose="020F0502020204030204"/>
+                <a:ea typeface="+mn-ea"/>
+                <a:cs typeface="+mn-cs"/>
+              </a:rPr>
+              <a:t>In a resource constrained Kenyan clinical setting, Logistic Regression + Lasso is a strong alternative</a:t>
+            </a:r>
+            <a:endParaRPr kumimoji="0" lang="en-US" sz="850" b="0" i="0" u="none" strike="noStrike" kern="1200" cap="none" spc="0" normalizeH="0" baseline="0" noProof="0" dirty="0">
+              <a:ln>
+                <a:noFill/>
+              </a:ln>
+              <a:solidFill>
+                <a:prstClr val="black"/>
+              </a:solidFill>
+              <a:effectLst/>
+              <a:uLnTx/>
+              <a:uFillTx/>
+              <a:latin typeface="Calibri" panose="020F0502020204030204"/>
+              <a:ea typeface="+mn-ea"/>
+              <a:cs typeface="+mn-cs"/>
+            </a:endParaRPr>
+          </a:p>
+        </p:txBody>
+      </p:sp>
+    </p:spTree>
+  </p:cSld>
+  <p:clrMapOvr>
+    <a:masterClrMapping/>
+  </p:clrMapOvr>
+</p:sld>
+</file>
+
+<file path=ppt/slides/slide11.xml><?xml version="1.0" encoding="utf-8"?>
+<p:sld xmlns:a="http://schemas.openxmlformats.org/drawingml/2006/main" xmlns:r="http://schemas.openxmlformats.org/officeDocument/2006/relationships" xmlns:p="http://schemas.openxmlformats.org/presentationml/2006/main">
+  <p:cSld name="Slide 9">
+    <p:bg>
+      <p:bgPr>
+        <a:solidFill>
+          <a:srgbClr val="F0F4F8"/>
+        </a:solidFill>
+        <a:effectLst/>
+      </p:bgPr>
+    </p:bg>
+    <p:spTree>
+      <p:nvGrpSpPr>
+        <p:cNvPr id="1" name=""/>
+        <p:cNvGrpSpPr/>
+        <p:nvPr/>
+      </p:nvGrpSpPr>
+      <p:grpSpPr>
+        <a:xfrm>
+          <a:off x="0" y="0"/>
+          <a:ext cx="0" cy="0"/>
+          <a:chOff x="0" y="0"/>
+          <a:chExt cx="0" cy="0"/>
+        </a:xfrm>
+      </p:grpSpPr>
+      <p:sp>
+        <p:nvSpPr>
+          <p:cNvPr id="2" name="Shape 0"/>
+          <p:cNvSpPr/>
+          <p:nvPr/>
+        </p:nvSpPr>
+        <p:spPr>
+          <a:xfrm>
+            <a:off x="0" y="0"/>
+            <a:ext cx="9144000" cy="1005840"/>
+          </a:xfrm>
+          <a:prstGeom prst="rect">
+            <a:avLst/>
+          </a:prstGeom>
+          <a:solidFill>
+            <a:schemeClr val="accent1">
+              <a:lumMod val="50000"/>
+            </a:schemeClr>
+          </a:solidFill>
+          <a:ln/>
+        </p:spPr>
+      </p:sp>
+      <p:sp>
+        <p:nvSpPr>
+          <p:cNvPr id="3" name="Text 1"/>
+          <p:cNvSpPr/>
+          <p:nvPr/>
+        </p:nvSpPr>
+        <p:spPr>
+          <a:xfrm>
+            <a:off x="457200" y="182880"/>
+            <a:ext cx="8229600" cy="640080"/>
+          </a:xfrm>
+          <a:prstGeom prst="rect">
+            <a:avLst/>
+          </a:prstGeom>
+          <a:noFill/>
+          <a:ln/>
+        </p:spPr>
+        <p:txBody>
+          <a:bodyPr wrap="square" rtlCol="0" anchor="ctr"/>
+          <a:lstStyle/>
+          <a:p>
+            <a:pPr marL="0" indent="0">
+              <a:buNone/>
+            </a:pPr>
+            <a:r>
+              <a:rPr lang="en-US" sz="2200" b="1" dirty="0">
+                <a:solidFill>
+                  <a:srgbClr val="FFFFFF"/>
+                </a:solidFill>
+              </a:rPr>
+              <a:t>WHAT DRIVES VACCINATION?</a:t>
+            </a:r>
+            <a:endParaRPr lang="en-US" sz="2200" dirty="0"/>
+          </a:p>
+        </p:txBody>
+      </p:sp>
+      <p:sp>
+        <p:nvSpPr>
+          <p:cNvPr id="4" name="Text 2"/>
+          <p:cNvSpPr/>
+          <p:nvPr/>
+        </p:nvSpPr>
+        <p:spPr>
+          <a:xfrm>
+            <a:off x="274320" y="1051560"/>
+            <a:ext cx="8595360" cy="365760"/>
+          </a:xfrm>
+          <a:prstGeom prst="rect">
+            <a:avLst/>
+          </a:prstGeom>
+          <a:noFill/>
+          <a:ln/>
+        </p:spPr>
+        <p:txBody>
+          <a:bodyPr wrap="square" rtlCol="0" anchor="ctr"/>
+          <a:lstStyle/>
+          <a:p>
+            <a:pPr marL="0" indent="0">
+              <a:buNone/>
+            </a:pPr>
+            <a:r>
+              <a:rPr lang="en-US" sz="1200" i="1" dirty="0">
+                <a:solidFill>
+                  <a:srgbClr val="64748B"/>
+                </a:solidFill>
+              </a:rPr>
+              <a:t>Top Predictors from Random Forest Feature Importance</a:t>
+            </a:r>
+            <a:endParaRPr lang="en-US" sz="1200" dirty="0"/>
+          </a:p>
+        </p:txBody>
+      </p:sp>
+      <p:sp>
+        <p:nvSpPr>
+          <p:cNvPr id="5" name="Shape 3"/>
+          <p:cNvSpPr/>
+          <p:nvPr/>
+        </p:nvSpPr>
+        <p:spPr>
+          <a:xfrm>
+            <a:off x="2560320" y="1508760"/>
+            <a:ext cx="2139696" cy="292608"/>
+          </a:xfrm>
+          <a:prstGeom prst="rect">
+            <a:avLst/>
+          </a:prstGeom>
+          <a:solidFill>
+            <a:srgbClr val="4A0000"/>
+          </a:solidFill>
+          <a:ln/>
+        </p:spPr>
+      </p:sp>
+      <p:sp>
+        <p:nvSpPr>
+          <p:cNvPr id="6" name="Text 4"/>
+          <p:cNvSpPr/>
+          <p:nvPr/>
+        </p:nvSpPr>
+        <p:spPr>
+          <a:xfrm>
+            <a:off x="274320" y="1508760"/>
+            <a:ext cx="2240280" cy="292608"/>
+          </a:xfrm>
+          <a:prstGeom prst="rect">
+            <a:avLst/>
+          </a:prstGeom>
+          <a:noFill/>
+          <a:ln/>
+        </p:spPr>
+        <p:txBody>
+          <a:bodyPr wrap="square" lIns="0" tIns="0" rIns="0" bIns="0" rtlCol="0" anchor="ctr"/>
+          <a:lstStyle/>
+          <a:p>
+            <a:pPr marL="0" indent="0">
+              <a:buNone/>
+            </a:pPr>
+            <a:r>
+              <a:rPr lang="en-US" sz="900" b="1" dirty="0">
+                <a:solidFill>
+                  <a:srgbClr val="0F1F3D"/>
+                </a:solidFill>
+              </a:rPr>
+              <a:t>opinion_seas_risk</a:t>
+            </a:r>
+            <a:endParaRPr lang="en-US" sz="900" dirty="0"/>
+          </a:p>
+        </p:txBody>
+      </p:sp>
+      <p:sp>
+        <p:nvSpPr>
+          <p:cNvPr id="7" name="Text 5"/>
+          <p:cNvSpPr/>
+          <p:nvPr/>
+        </p:nvSpPr>
+        <p:spPr>
+          <a:xfrm>
+            <a:off x="4745736" y="1508760"/>
+            <a:ext cx="731520" cy="292608"/>
+          </a:xfrm>
+          <a:prstGeom prst="rect">
+            <a:avLst/>
+          </a:prstGeom>
+          <a:noFill/>
+          <a:ln/>
+        </p:spPr>
+        <p:txBody>
+          <a:bodyPr wrap="square" lIns="0" tIns="0" rIns="0" bIns="0" rtlCol="0" anchor="ctr"/>
+          <a:lstStyle/>
+          <a:p>
+            <a:pPr marL="0" indent="0">
+              <a:buNone/>
+            </a:pPr>
+            <a:r>
+              <a:rPr lang="en-US" sz="900" b="1" dirty="0">
+                <a:solidFill>
+                  <a:srgbClr val="4A0000"/>
+                </a:solidFill>
+              </a:rPr>
+              <a:t>r=0.39</a:t>
+            </a:r>
+            <a:endParaRPr lang="en-US" sz="900" dirty="0"/>
+          </a:p>
+        </p:txBody>
+      </p:sp>
+      <p:sp>
+        <p:nvSpPr>
+          <p:cNvPr id="8" name="Shape 6"/>
+          <p:cNvSpPr/>
+          <p:nvPr/>
+        </p:nvSpPr>
+        <p:spPr>
+          <a:xfrm>
+            <a:off x="2560320" y="1956816"/>
+            <a:ext cx="2024482" cy="292608"/>
+          </a:xfrm>
+          <a:prstGeom prst="rect">
+            <a:avLst/>
+          </a:prstGeom>
+          <a:solidFill>
+            <a:srgbClr val="0F1F3D"/>
+          </a:solidFill>
+          <a:ln/>
+        </p:spPr>
+      </p:sp>
+      <p:sp>
+        <p:nvSpPr>
+          <p:cNvPr id="9" name="Text 7"/>
+          <p:cNvSpPr/>
+          <p:nvPr/>
+        </p:nvSpPr>
+        <p:spPr>
+          <a:xfrm>
+            <a:off x="274320" y="1956816"/>
+            <a:ext cx="2240280" cy="292608"/>
+          </a:xfrm>
+          <a:prstGeom prst="rect">
+            <a:avLst/>
+          </a:prstGeom>
+          <a:noFill/>
+          <a:ln/>
+        </p:spPr>
+        <p:txBody>
+          <a:bodyPr wrap="square" lIns="0" tIns="0" rIns="0" bIns="0" rtlCol="0" anchor="ctr"/>
+          <a:lstStyle/>
+          <a:p>
+            <a:pPr marL="0" indent="0">
+              <a:buNone/>
+            </a:pPr>
+            <a:r>
+              <a:rPr lang="en-US" sz="900" b="1" dirty="0">
+                <a:solidFill>
+                  <a:srgbClr val="0F1F3D"/>
+                </a:solidFill>
+              </a:rPr>
+              <a:t>doctor_recc_seasonal</a:t>
+            </a:r>
+            <a:endParaRPr lang="en-US" sz="900" dirty="0"/>
+          </a:p>
+        </p:txBody>
+      </p:sp>
+      <p:sp>
+        <p:nvSpPr>
+          <p:cNvPr id="10" name="Text 8"/>
+          <p:cNvSpPr/>
+          <p:nvPr/>
+        </p:nvSpPr>
+        <p:spPr>
+          <a:xfrm>
+            <a:off x="4630522" y="1956816"/>
+            <a:ext cx="731520" cy="292608"/>
+          </a:xfrm>
+          <a:prstGeom prst="rect">
+            <a:avLst/>
+          </a:prstGeom>
+          <a:noFill/>
+          <a:ln/>
+        </p:spPr>
+        <p:txBody>
+          <a:bodyPr wrap="square" lIns="0" tIns="0" rIns="0" bIns="0" rtlCol="0" anchor="ctr"/>
+          <a:lstStyle/>
+          <a:p>
+            <a:pPr marL="0" indent="0">
+              <a:buNone/>
+            </a:pPr>
+            <a:r>
+              <a:rPr lang="en-US" sz="900" b="1" dirty="0">
+                <a:solidFill>
+                  <a:srgbClr val="0F1F3D"/>
+                </a:solidFill>
+              </a:rPr>
+              <a:t>r=0.369</a:t>
+            </a:r>
+            <a:endParaRPr lang="en-US" sz="900" dirty="0"/>
+          </a:p>
+        </p:txBody>
+      </p:sp>
+      <p:sp>
+        <p:nvSpPr>
+          <p:cNvPr id="11" name="Shape 9"/>
+          <p:cNvSpPr/>
+          <p:nvPr/>
+        </p:nvSpPr>
+        <p:spPr>
+          <a:xfrm>
+            <a:off x="2560320" y="2404872"/>
+            <a:ext cx="1986077" cy="292608"/>
+          </a:xfrm>
+          <a:prstGeom prst="rect">
+            <a:avLst/>
+          </a:prstGeom>
+          <a:solidFill>
+            <a:srgbClr val="8B4513"/>
+          </a:solidFill>
+          <a:ln/>
+        </p:spPr>
+      </p:sp>
+      <p:sp>
+        <p:nvSpPr>
+          <p:cNvPr id="12" name="Text 10"/>
+          <p:cNvSpPr/>
+          <p:nvPr/>
+        </p:nvSpPr>
+        <p:spPr>
+          <a:xfrm>
+            <a:off x="274320" y="2404872"/>
+            <a:ext cx="2240280" cy="292608"/>
+          </a:xfrm>
+          <a:prstGeom prst="rect">
+            <a:avLst/>
+          </a:prstGeom>
+          <a:noFill/>
+          <a:ln/>
+        </p:spPr>
+        <p:txBody>
+          <a:bodyPr wrap="square" lIns="0" tIns="0" rIns="0" bIns="0" rtlCol="0" anchor="ctr"/>
+          <a:lstStyle/>
+          <a:p>
+            <a:pPr marL="0" indent="0">
+              <a:buNone/>
+            </a:pPr>
+            <a:r>
+              <a:rPr lang="en-US" sz="900" b="1" dirty="0">
+                <a:solidFill>
+                  <a:srgbClr val="0F1F3D"/>
+                </a:solidFill>
+              </a:rPr>
+              <a:t>opinion_seas_vacc_effective</a:t>
+            </a:r>
+            <a:endParaRPr lang="en-US" sz="900" dirty="0"/>
+          </a:p>
+        </p:txBody>
+      </p:sp>
+      <p:sp>
+        <p:nvSpPr>
+          <p:cNvPr id="13" name="Text 11"/>
+          <p:cNvSpPr/>
+          <p:nvPr/>
+        </p:nvSpPr>
+        <p:spPr>
+          <a:xfrm>
+            <a:off x="4592117" y="2404872"/>
+            <a:ext cx="731520" cy="292608"/>
+          </a:xfrm>
+          <a:prstGeom prst="rect">
+            <a:avLst/>
+          </a:prstGeom>
+          <a:noFill/>
+          <a:ln/>
+        </p:spPr>
+        <p:txBody>
+          <a:bodyPr wrap="square" lIns="0" tIns="0" rIns="0" bIns="0" rtlCol="0" anchor="ctr"/>
+          <a:lstStyle/>
+          <a:p>
+            <a:pPr marL="0" indent="0">
+              <a:buNone/>
+            </a:pPr>
+            <a:r>
+              <a:rPr lang="en-US" sz="900" b="1" dirty="0">
+                <a:solidFill>
+                  <a:srgbClr val="8B4513"/>
+                </a:solidFill>
+              </a:rPr>
+              <a:t>r=0.362</a:t>
+            </a:r>
+            <a:endParaRPr lang="en-US" sz="900" dirty="0"/>
+          </a:p>
+        </p:txBody>
+      </p:sp>
+      <p:sp>
+        <p:nvSpPr>
+          <p:cNvPr id="14" name="Shape 12"/>
+          <p:cNvSpPr/>
+          <p:nvPr/>
+        </p:nvSpPr>
+        <p:spPr>
+          <a:xfrm>
+            <a:off x="2560320" y="2852928"/>
+            <a:ext cx="1102766" cy="292608"/>
+          </a:xfrm>
+          <a:prstGeom prst="rect">
+            <a:avLst/>
+          </a:prstGeom>
+          <a:solidFill>
+            <a:srgbClr val="006400"/>
+          </a:solidFill>
+          <a:ln/>
+        </p:spPr>
+      </p:sp>
+      <p:sp>
+        <p:nvSpPr>
+          <p:cNvPr id="15" name="Text 13"/>
+          <p:cNvSpPr/>
+          <p:nvPr/>
+        </p:nvSpPr>
+        <p:spPr>
+          <a:xfrm>
+            <a:off x="274320" y="2852928"/>
+            <a:ext cx="2240280" cy="292608"/>
+          </a:xfrm>
+          <a:prstGeom prst="rect">
+            <a:avLst/>
+          </a:prstGeom>
+          <a:noFill/>
+          <a:ln/>
+        </p:spPr>
+        <p:txBody>
+          <a:bodyPr wrap="square" lIns="0" tIns="0" rIns="0" bIns="0" rtlCol="0" anchor="ctr"/>
+          <a:lstStyle/>
+          <a:p>
+            <a:pPr marL="0" indent="0">
+              <a:buNone/>
+            </a:pPr>
+            <a:r>
+              <a:rPr lang="en-US" sz="900" b="1" dirty="0">
+                <a:solidFill>
+                  <a:srgbClr val="0F1F3D"/>
+                </a:solidFill>
+              </a:rPr>
+              <a:t>health_insurance</a:t>
+            </a:r>
+            <a:endParaRPr lang="en-US" sz="900" dirty="0"/>
+          </a:p>
+        </p:txBody>
+      </p:sp>
+      <p:sp>
+        <p:nvSpPr>
+          <p:cNvPr id="16" name="Text 14"/>
+          <p:cNvSpPr/>
+          <p:nvPr/>
+        </p:nvSpPr>
+        <p:spPr>
+          <a:xfrm>
+            <a:off x="3708806" y="2852928"/>
+            <a:ext cx="731520" cy="292608"/>
+          </a:xfrm>
+          <a:prstGeom prst="rect">
+            <a:avLst/>
+          </a:prstGeom>
+          <a:noFill/>
+          <a:ln/>
+        </p:spPr>
+        <p:txBody>
+          <a:bodyPr wrap="square" lIns="0" tIns="0" rIns="0" bIns="0" rtlCol="0" anchor="ctr"/>
+          <a:lstStyle/>
+          <a:p>
+            <a:pPr marL="0" indent="0">
+              <a:buNone/>
+            </a:pPr>
+            <a:r>
+              <a:rPr lang="en-US" sz="900" b="1" dirty="0">
+                <a:solidFill>
+                  <a:srgbClr val="006400"/>
+                </a:solidFill>
+              </a:rPr>
+              <a:t>r=0.201</a:t>
+            </a:r>
+            <a:endParaRPr lang="en-US" sz="900" dirty="0"/>
+          </a:p>
+        </p:txBody>
+      </p:sp>
+      <p:sp>
+        <p:nvSpPr>
+          <p:cNvPr id="17" name="Shape 15"/>
+          <p:cNvSpPr/>
+          <p:nvPr/>
+        </p:nvSpPr>
+        <p:spPr>
+          <a:xfrm>
+            <a:off x="2560320" y="3300984"/>
+            <a:ext cx="932688" cy="292608"/>
+          </a:xfrm>
+          <a:prstGeom prst="rect">
+            <a:avLst/>
+          </a:prstGeom>
+          <a:solidFill>
+            <a:srgbClr val="4B0082"/>
+          </a:solidFill>
+          <a:ln/>
+        </p:spPr>
+      </p:sp>
+      <p:sp>
+        <p:nvSpPr>
+          <p:cNvPr id="18" name="Text 16"/>
+          <p:cNvSpPr/>
+          <p:nvPr/>
+        </p:nvSpPr>
+        <p:spPr>
+          <a:xfrm>
+            <a:off x="274320" y="3300984"/>
+            <a:ext cx="2240280" cy="292608"/>
+          </a:xfrm>
+          <a:prstGeom prst="rect">
+            <a:avLst/>
+          </a:prstGeom>
+          <a:noFill/>
+          <a:ln/>
+        </p:spPr>
+        <p:txBody>
+          <a:bodyPr wrap="square" lIns="0" tIns="0" rIns="0" bIns="0" rtlCol="0" anchor="ctr"/>
+          <a:lstStyle/>
+          <a:p>
+            <a:pPr marL="0" indent="0">
+              <a:buNone/>
+            </a:pPr>
+            <a:r>
+              <a:rPr lang="en-US" sz="900" b="1" dirty="0">
+                <a:solidFill>
+                  <a:srgbClr val="0F1F3D"/>
+                </a:solidFill>
+              </a:rPr>
+              <a:t>chronic_med_condition</a:t>
+            </a:r>
+            <a:endParaRPr lang="en-US" sz="900" dirty="0"/>
+          </a:p>
+        </p:txBody>
+      </p:sp>
+      <p:sp>
+        <p:nvSpPr>
+          <p:cNvPr id="19" name="Text 17"/>
+          <p:cNvSpPr/>
+          <p:nvPr/>
+        </p:nvSpPr>
+        <p:spPr>
+          <a:xfrm>
+            <a:off x="3538728" y="3300984"/>
+            <a:ext cx="731520" cy="292608"/>
+          </a:xfrm>
+          <a:prstGeom prst="rect">
+            <a:avLst/>
+          </a:prstGeom>
+          <a:noFill/>
+          <a:ln/>
+        </p:spPr>
+        <p:txBody>
+          <a:bodyPr wrap="square" lIns="0" tIns="0" rIns="0" bIns="0" rtlCol="0" anchor="ctr"/>
+          <a:lstStyle/>
+          <a:p>
+            <a:pPr marL="0" indent="0">
+              <a:buNone/>
+            </a:pPr>
+            <a:r>
+              <a:rPr lang="en-US" sz="900" b="1" dirty="0">
+                <a:solidFill>
+                  <a:srgbClr val="4B0082"/>
+                </a:solidFill>
+              </a:rPr>
+              <a:t>r=0.17</a:t>
+            </a:r>
+            <a:endParaRPr lang="en-US" sz="900" dirty="0"/>
+          </a:p>
+        </p:txBody>
+      </p:sp>
+      <p:sp>
+        <p:nvSpPr>
+          <p:cNvPr id="20" name="Shape 18"/>
+          <p:cNvSpPr/>
+          <p:nvPr/>
+        </p:nvSpPr>
+        <p:spPr>
+          <a:xfrm>
+            <a:off x="2560320" y="3749040"/>
+            <a:ext cx="696773" cy="292608"/>
+          </a:xfrm>
+          <a:prstGeom prst="rect">
+            <a:avLst/>
+          </a:prstGeom>
+          <a:solidFill>
+            <a:srgbClr val="8B0000"/>
+          </a:solidFill>
+          <a:ln/>
+        </p:spPr>
+      </p:sp>
+      <p:sp>
+        <p:nvSpPr>
+          <p:cNvPr id="21" name="Text 19"/>
+          <p:cNvSpPr/>
+          <p:nvPr/>
+        </p:nvSpPr>
+        <p:spPr>
+          <a:xfrm>
+            <a:off x="274320" y="3749040"/>
+            <a:ext cx="2240280" cy="292608"/>
+          </a:xfrm>
+          <a:prstGeom prst="rect">
+            <a:avLst/>
+          </a:prstGeom>
+          <a:noFill/>
+          <a:ln/>
+        </p:spPr>
+        <p:txBody>
+          <a:bodyPr wrap="square" lIns="0" tIns="0" rIns="0" bIns="0" rtlCol="0" anchor="ctr"/>
+          <a:lstStyle/>
+          <a:p>
+            <a:pPr marL="0" indent="0">
+              <a:buNone/>
+            </a:pPr>
+            <a:r>
+              <a:rPr lang="en-US" sz="900" b="1" dirty="0">
+                <a:solidFill>
+                  <a:srgbClr val="0F1F3D"/>
+                </a:solidFill>
+              </a:rPr>
+              <a:t>health_worker</a:t>
+            </a:r>
+            <a:endParaRPr lang="en-US" sz="900" dirty="0"/>
+          </a:p>
+        </p:txBody>
+      </p:sp>
+      <p:sp>
+        <p:nvSpPr>
+          <p:cNvPr id="22" name="Text 20"/>
+          <p:cNvSpPr/>
+          <p:nvPr/>
+        </p:nvSpPr>
+        <p:spPr>
+          <a:xfrm>
+            <a:off x="3302813" y="3749040"/>
+            <a:ext cx="731520" cy="292608"/>
+          </a:xfrm>
+          <a:prstGeom prst="rect">
+            <a:avLst/>
+          </a:prstGeom>
+          <a:noFill/>
+          <a:ln/>
+        </p:spPr>
+        <p:txBody>
+          <a:bodyPr wrap="square" lIns="0" tIns="0" rIns="0" bIns="0" rtlCol="0" anchor="ctr"/>
+          <a:lstStyle/>
+          <a:p>
+            <a:pPr marL="0" indent="0">
+              <a:buNone/>
+            </a:pPr>
+            <a:r>
+              <a:rPr lang="en-US" sz="900" b="1" dirty="0">
+                <a:solidFill>
+                  <a:srgbClr val="8B0000"/>
+                </a:solidFill>
+              </a:rPr>
+              <a:t>r=0.127</a:t>
+            </a:r>
+            <a:endParaRPr lang="en-US" sz="900" dirty="0"/>
+          </a:p>
+        </p:txBody>
+      </p:sp>
+      <p:sp>
+        <p:nvSpPr>
+          <p:cNvPr id="23" name="Shape 21"/>
+          <p:cNvSpPr/>
+          <p:nvPr/>
+        </p:nvSpPr>
+        <p:spPr>
+          <a:xfrm>
+            <a:off x="2560320" y="4197096"/>
+            <a:ext cx="658368" cy="292608"/>
+          </a:xfrm>
+          <a:prstGeom prst="rect">
+            <a:avLst/>
+          </a:prstGeom>
+          <a:solidFill>
+            <a:srgbClr val="4A0000"/>
+          </a:solidFill>
+          <a:ln/>
+        </p:spPr>
+      </p:sp>
+      <p:sp>
+        <p:nvSpPr>
+          <p:cNvPr id="24" name="Text 22"/>
+          <p:cNvSpPr/>
+          <p:nvPr/>
+        </p:nvSpPr>
+        <p:spPr>
+          <a:xfrm>
+            <a:off x="274320" y="4197096"/>
+            <a:ext cx="2240280" cy="292608"/>
+          </a:xfrm>
+          <a:prstGeom prst="rect">
+            <a:avLst/>
+          </a:prstGeom>
+          <a:noFill/>
+          <a:ln/>
+        </p:spPr>
+        <p:txBody>
+          <a:bodyPr wrap="square" lIns="0" tIns="0" rIns="0" bIns="0" rtlCol="0" anchor="ctr"/>
+          <a:lstStyle/>
+          <a:p>
+            <a:pPr marL="0" indent="0">
+              <a:buNone/>
+            </a:pPr>
+            <a:r>
+              <a:rPr lang="en-US" sz="900" b="1" dirty="0">
+                <a:solidFill>
+                  <a:srgbClr val="0F1F3D"/>
+                </a:solidFill>
+              </a:rPr>
+              <a:t>behavioral_touch_face</a:t>
+            </a:r>
+            <a:endParaRPr lang="en-US" sz="900" dirty="0"/>
+          </a:p>
+        </p:txBody>
+      </p:sp>
+      <p:sp>
+        <p:nvSpPr>
+          <p:cNvPr id="25" name="Text 23"/>
+          <p:cNvSpPr/>
+          <p:nvPr/>
+        </p:nvSpPr>
+        <p:spPr>
+          <a:xfrm>
+            <a:off x="3264408" y="4197096"/>
+            <a:ext cx="731520" cy="292608"/>
+          </a:xfrm>
+          <a:prstGeom prst="rect">
+            <a:avLst/>
+          </a:prstGeom>
+          <a:noFill/>
+          <a:ln/>
+        </p:spPr>
+        <p:txBody>
+          <a:bodyPr wrap="square" lIns="0" tIns="0" rIns="0" bIns="0" rtlCol="0" anchor="ctr"/>
+          <a:lstStyle/>
+          <a:p>
+            <a:pPr marL="0" indent="0">
+              <a:buNone/>
+            </a:pPr>
+            <a:r>
+              <a:rPr lang="en-US" sz="900" b="1" dirty="0">
+                <a:solidFill>
+                  <a:srgbClr val="4A0000"/>
+                </a:solidFill>
+              </a:rPr>
+              <a:t>r=0.12</a:t>
+            </a:r>
+            <a:endParaRPr lang="en-US" sz="900" dirty="0"/>
+          </a:p>
+        </p:txBody>
+      </p:sp>
+      <p:sp>
+        <p:nvSpPr>
+          <p:cNvPr id="26" name="Shape 24"/>
+          <p:cNvSpPr/>
+          <p:nvPr/>
+        </p:nvSpPr>
+        <p:spPr>
+          <a:xfrm>
+            <a:off x="2560320" y="4645152"/>
+            <a:ext cx="614477" cy="292608"/>
+          </a:xfrm>
+          <a:prstGeom prst="rect">
+            <a:avLst/>
+          </a:prstGeom>
+          <a:solidFill>
+            <a:srgbClr val="0F1F3D"/>
+          </a:solidFill>
+          <a:ln/>
+        </p:spPr>
+      </p:sp>
+      <p:sp>
+        <p:nvSpPr>
+          <p:cNvPr id="27" name="Text 25"/>
+          <p:cNvSpPr/>
+          <p:nvPr/>
+        </p:nvSpPr>
+        <p:spPr>
+          <a:xfrm>
+            <a:off x="274320" y="4645152"/>
+            <a:ext cx="2240280" cy="292608"/>
+          </a:xfrm>
+          <a:prstGeom prst="rect">
+            <a:avLst/>
+          </a:prstGeom>
+          <a:noFill/>
+          <a:ln/>
+        </p:spPr>
+        <p:txBody>
+          <a:bodyPr wrap="square" lIns="0" tIns="0" rIns="0" bIns="0" rtlCol="0" anchor="ctr"/>
+          <a:lstStyle/>
+          <a:p>
+            <a:pPr marL="0" indent="0">
+              <a:buNone/>
+            </a:pPr>
+            <a:r>
+              <a:rPr lang="en-US" sz="900" b="1" dirty="0">
+                <a:solidFill>
+                  <a:srgbClr val="0F1F3D"/>
+                </a:solidFill>
+              </a:rPr>
+              <a:t>behavioral_wash_hands</a:t>
+            </a:r>
+            <a:endParaRPr lang="en-US" sz="900" dirty="0"/>
+          </a:p>
+        </p:txBody>
+      </p:sp>
+      <p:sp>
+        <p:nvSpPr>
+          <p:cNvPr id="28" name="Text 26"/>
+          <p:cNvSpPr/>
+          <p:nvPr/>
+        </p:nvSpPr>
+        <p:spPr>
+          <a:xfrm>
+            <a:off x="3220517" y="4645152"/>
+            <a:ext cx="731520" cy="292608"/>
+          </a:xfrm>
+          <a:prstGeom prst="rect">
+            <a:avLst/>
+          </a:prstGeom>
+          <a:noFill/>
+          <a:ln/>
+        </p:spPr>
+        <p:txBody>
+          <a:bodyPr wrap="square" lIns="0" tIns="0" rIns="0" bIns="0" rtlCol="0" anchor="ctr"/>
+          <a:lstStyle/>
+          <a:p>
+            <a:pPr marL="0" indent="0">
+              <a:buNone/>
+            </a:pPr>
+            <a:r>
+              <a:rPr lang="en-US" sz="900" b="1" dirty="0">
+                <a:solidFill>
+                  <a:srgbClr val="0F1F3D"/>
+                </a:solidFill>
+              </a:rPr>
+              <a:t>r=0.112</a:t>
+            </a:r>
+            <a:endParaRPr lang="en-US" sz="900" dirty="0"/>
+          </a:p>
+        </p:txBody>
+      </p:sp>
+    </p:spTree>
+  </p:cSld>
+  <p:clrMapOvr>
+    <a:masterClrMapping/>
+  </p:clrMapOvr>
+</p:sld>
+</file>
+
+<file path=ppt/slides/slide12.xml><?xml version="1.0" encoding="utf-8"?>
+<p:sld xmlns:a="http://schemas.openxmlformats.org/drawingml/2006/main" xmlns:r="http://schemas.openxmlformats.org/officeDocument/2006/relationships" xmlns:p="http://schemas.openxmlformats.org/presentationml/2006/main">
   <p:cSld name="Slide 10">
     <p:bg>
       <p:bgPr>
@@ -2708,7 +6289,7 @@
 </p:sld>
 </file>
 
-<file path=ppt/slides/slide11.xml><?xml version="1.0" encoding="utf-8"?>
+<file path=ppt/slides/slide13.xml><?xml version="1.0" encoding="utf-8"?>
 <p:sld xmlns:a="http://schemas.openxmlformats.org/drawingml/2006/main" xmlns:r="http://schemas.openxmlformats.org/officeDocument/2006/relationships" xmlns:p="http://schemas.openxmlformats.org/presentationml/2006/main">
   <p:cSld name="Slide 11">
     <p:bg>
@@ -3287,7 +6868,7 @@
 </p:sld>
 </file>
 
-<file path=ppt/slides/slide12.xml><?xml version="1.0" encoding="utf-8"?>
+<file path=ppt/slides/slide14.xml><?xml version="1.0" encoding="utf-8"?>
 <p:sld xmlns:a="http://schemas.openxmlformats.org/drawingml/2006/main" xmlns:r="http://schemas.openxmlformats.org/officeDocument/2006/relationships" xmlns:p="http://schemas.openxmlformats.org/presentationml/2006/main">
   <p:cSld name="Slide 12">
     <p:bg>
@@ -4191,7 +7772,7 @@
 </p:sld>
 </file>
 
-<file path=ppt/slides/slide13.xml><?xml version="1.0" encoding="utf-8"?>
+<file path=ppt/slides/slide15.xml><?xml version="1.0" encoding="utf-8"?>
 <p:sld xmlns:a="http://schemas.openxmlformats.org/drawingml/2006/main" xmlns:r="http://schemas.openxmlformats.org/officeDocument/2006/relationships" xmlns:p="http://schemas.openxmlformats.org/presentationml/2006/main">
   <p:cSld name="Slide 13">
     <p:bg>
@@ -5095,7 +8676,7 @@
 </p:sld>
 </file>
 
-<file path=ppt/slides/slide14.xml><?xml version="1.0" encoding="utf-8"?>
+<file path=ppt/slides/slide16.xml><?xml version="1.0" encoding="utf-8"?>
 <p:sld xmlns:a="http://schemas.openxmlformats.org/drawingml/2006/main" xmlns:r="http://schemas.openxmlformats.org/officeDocument/2006/relationships" xmlns:p="http://schemas.openxmlformats.org/presentationml/2006/main">
   <p:cSld name="Slide 14">
     <p:bg>
@@ -5401,7 +8982,15 @@
                   <a:srgbClr val="64748B"/>
                 </a:solidFill>
               </a:rPr>
-              <a:t>Best Model: Random Forest  |  ROC AUC: 0.8518  |  Thank you</a:t>
+              <a:t>Best Model: Random Forest  |  ROC AUC: </a:t>
+            </a:r>
+            <a:r>
+              <a:rPr lang="en-US" sz="1000">
+                <a:solidFill>
+                  <a:srgbClr val="64748B"/>
+                </a:solidFill>
+              </a:rPr>
+              <a:t>0.8518  </a:t>
             </a:r>
             <a:endParaRPr lang="en-US" sz="1000" dirty="0"/>
           </a:p>
@@ -5415,7 +9004,7 @@
 </p:sld>
 </file>
 
-<file path=ppt/slides/slide15.xml><?xml version="1.0" encoding="utf-8"?>
+<file path=ppt/slides/slide17.xml><?xml version="1.0" encoding="utf-8"?>
 <p:sld xmlns:a="http://schemas.openxmlformats.org/drawingml/2006/main" xmlns:r="http://schemas.openxmlformats.org/officeDocument/2006/relationships" xmlns:p="http://schemas.openxmlformats.org/presentationml/2006/main">
   <p:cSld>
     <p:bg>
@@ -5567,6 +9156,282 @@
 
 <file path=ppt/slides/slide2.xml><?xml version="1.0" encoding="utf-8"?>
 <p:sld xmlns:a="http://schemas.openxmlformats.org/drawingml/2006/main" xmlns:r="http://schemas.openxmlformats.org/officeDocument/2006/relationships" xmlns:p="http://schemas.openxmlformats.org/presentationml/2006/main">
+  <p:cSld>
+    <p:bg>
+      <p:bgPr>
+        <a:solidFill>
+          <a:srgbClr val="F0F4F8"/>
+        </a:solidFill>
+        <a:effectLst/>
+      </p:bgPr>
+    </p:bg>
+    <p:spTree>
+      <p:nvGrpSpPr>
+        <p:cNvPr id="1" name="">
+          <a:extLst>
+            <a:ext uri="{FF2B5EF4-FFF2-40B4-BE49-F238E27FC236}">
+              <a16:creationId xmlns:a16="http://schemas.microsoft.com/office/drawing/2014/main" id="{4F5C7794-E5FE-C3E3-53B2-E990FF012BC0}"/>
+            </a:ext>
+          </a:extLst>
+        </p:cNvPr>
+        <p:cNvGrpSpPr/>
+        <p:nvPr/>
+      </p:nvGrpSpPr>
+      <p:grpSpPr>
+        <a:xfrm>
+          <a:off x="0" y="0"/>
+          <a:ext cx="0" cy="0"/>
+          <a:chOff x="0" y="0"/>
+          <a:chExt cx="0" cy="0"/>
+        </a:xfrm>
+      </p:grpSpPr>
+      <p:sp>
+        <p:nvSpPr>
+          <p:cNvPr id="2" name="Shape 0">
+            <a:extLst>
+              <a:ext uri="{FF2B5EF4-FFF2-40B4-BE49-F238E27FC236}">
+                <a16:creationId xmlns:a16="http://schemas.microsoft.com/office/drawing/2014/main" id="{40DBAD86-CFCD-FCFE-95F2-C511A3066E0E}"/>
+              </a:ext>
+            </a:extLst>
+          </p:cNvPr>
+          <p:cNvSpPr/>
+          <p:nvPr/>
+        </p:nvSpPr>
+        <p:spPr>
+          <a:xfrm>
+            <a:off x="0" y="0"/>
+            <a:ext cx="9144000" cy="1005840"/>
+          </a:xfrm>
+          <a:prstGeom prst="rect">
+            <a:avLst/>
+          </a:prstGeom>
+          <a:solidFill>
+            <a:schemeClr val="accent1">
+              <a:lumMod val="50000"/>
+            </a:schemeClr>
+          </a:solidFill>
+          <a:ln/>
+        </p:spPr>
+      </p:sp>
+      <p:sp>
+        <p:nvSpPr>
+          <p:cNvPr id="3" name="Text 1">
+            <a:extLst>
+              <a:ext uri="{FF2B5EF4-FFF2-40B4-BE49-F238E27FC236}">
+                <a16:creationId xmlns:a16="http://schemas.microsoft.com/office/drawing/2014/main" id="{D6DE2CCB-D605-F893-6594-85652119B44B}"/>
+              </a:ext>
+            </a:extLst>
+          </p:cNvPr>
+          <p:cNvSpPr/>
+          <p:nvPr/>
+        </p:nvSpPr>
+        <p:spPr>
+          <a:xfrm>
+            <a:off x="457200" y="182880"/>
+            <a:ext cx="8229600" cy="640080"/>
+          </a:xfrm>
+          <a:prstGeom prst="rect">
+            <a:avLst/>
+          </a:prstGeom>
+          <a:noFill/>
+          <a:ln/>
+        </p:spPr>
+        <p:txBody>
+          <a:bodyPr wrap="square" rtlCol="0" anchor="ctr"/>
+          <a:lstStyle/>
+          <a:p>
+            <a:pPr marL="0" indent="0">
+              <a:buNone/>
+            </a:pPr>
+            <a:r>
+              <a:rPr lang="en-US" sz="2200" b="1" dirty="0">
+                <a:solidFill>
+                  <a:srgbClr val="FFFFFF"/>
+                </a:solidFill>
+              </a:rPr>
+              <a:t>INTRODUCTION</a:t>
+            </a:r>
+            <a:endParaRPr lang="en-US" sz="2200" dirty="0"/>
+          </a:p>
+        </p:txBody>
+      </p:sp>
+      <p:sp>
+        <p:nvSpPr>
+          <p:cNvPr id="4" name="Shape 2">
+            <a:extLst>
+              <a:ext uri="{FF2B5EF4-FFF2-40B4-BE49-F238E27FC236}">
+                <a16:creationId xmlns:a16="http://schemas.microsoft.com/office/drawing/2014/main" id="{20428B8D-31A9-ED6E-D766-BC9A2BC10BCA}"/>
+              </a:ext>
+            </a:extLst>
+          </p:cNvPr>
+          <p:cNvSpPr/>
+          <p:nvPr/>
+        </p:nvSpPr>
+        <p:spPr>
+          <a:xfrm>
+            <a:off x="1804181" y="1566438"/>
+            <a:ext cx="5535637" cy="2482948"/>
+          </a:xfrm>
+          <a:prstGeom prst="rect">
+            <a:avLst/>
+          </a:prstGeom>
+          <a:solidFill>
+            <a:srgbClr val="FFFFFF"/>
+          </a:solidFill>
+          <a:ln/>
+          <a:effectLst>
+            <a:outerShdw blurRad="101600" dist="38100" dir="8100000" algn="bl" rotWithShape="0">
+              <a:srgbClr val="000000">
+                <a:alpha val="15000"/>
+              </a:srgbClr>
+            </a:outerShdw>
+          </a:effectLst>
+        </p:spPr>
+        <p:txBody>
+          <a:bodyPr/>
+          <a:lstStyle/>
+          <a:p>
+            <a:r>
+              <a:rPr lang="en-US" sz="1400" dirty="0"/>
+              <a:t>Every flu season Kenya loses lives to a preventable disease.</a:t>
+            </a:r>
+          </a:p>
+          <a:p>
+            <a:r>
+              <a:rPr lang="en-US" sz="1400" dirty="0"/>
+              <a:t>We built a machine learning model to identify who is least </a:t>
+            </a:r>
+          </a:p>
+          <a:p>
+            <a:r>
+              <a:rPr lang="en-US" sz="1400" dirty="0"/>
+              <a:t>likely to vaccinate so that public health departments and </a:t>
+            </a:r>
+          </a:p>
+          <a:p>
+            <a:r>
+              <a:rPr lang="en-US" sz="1400" dirty="0"/>
+              <a:t>hospitals can intervene before it is too late.</a:t>
+            </a:r>
+          </a:p>
+          <a:p>
+            <a:endParaRPr lang="en-US" sz="1400" dirty="0"/>
+          </a:p>
+          <a:p>
+            <a:r>
+              <a:rPr lang="en-US" sz="1400" dirty="0"/>
+              <a:t>Using survey data from 26,707 respondents we identified </a:t>
+            </a:r>
+          </a:p>
+          <a:p>
+            <a:r>
+              <a:rPr lang="en-US" sz="1400" dirty="0"/>
+              <a:t>the strongest predictors of vaccination behavior and </a:t>
+            </a:r>
+          </a:p>
+          <a:p>
+            <a:r>
+              <a:rPr lang="en-US" sz="1400" dirty="0"/>
+              <a:t>generated specific recommendations for two stakeholders.</a:t>
+            </a:r>
+          </a:p>
+        </p:txBody>
+      </p:sp>
+      <p:sp>
+        <p:nvSpPr>
+          <p:cNvPr id="6" name="Text 4">
+            <a:extLst>
+              <a:ext uri="{FF2B5EF4-FFF2-40B4-BE49-F238E27FC236}">
+                <a16:creationId xmlns:a16="http://schemas.microsoft.com/office/drawing/2014/main" id="{A724D6C3-B82B-1F40-3EA9-7586368BE320}"/>
+              </a:ext>
+            </a:extLst>
+          </p:cNvPr>
+          <p:cNvSpPr/>
+          <p:nvPr/>
+        </p:nvSpPr>
+        <p:spPr>
+          <a:xfrm>
+            <a:off x="365760" y="1124712"/>
+            <a:ext cx="3840480" cy="301752"/>
+          </a:xfrm>
+          <a:prstGeom prst="rect">
+            <a:avLst/>
+          </a:prstGeom>
+          <a:noFill/>
+          <a:ln/>
+        </p:spPr>
+        <p:txBody>
+          <a:bodyPr wrap="square" lIns="0" tIns="0" rIns="0" bIns="0" rtlCol="0" anchor="ctr"/>
+          <a:lstStyle/>
+          <a:p>
+            <a:pPr marL="0" indent="0">
+              <a:buNone/>
+            </a:pPr>
+            <a:endParaRPr lang="en-US" sz="1200" dirty="0"/>
+          </a:p>
+        </p:txBody>
+      </p:sp>
+      <p:sp>
+        <p:nvSpPr>
+          <p:cNvPr id="7" name="Text 5">
+            <a:extLst>
+              <a:ext uri="{FF2B5EF4-FFF2-40B4-BE49-F238E27FC236}">
+                <a16:creationId xmlns:a16="http://schemas.microsoft.com/office/drawing/2014/main" id="{F1B32737-6706-ACE4-6C7E-79FB4FD7B62A}"/>
+              </a:ext>
+            </a:extLst>
+          </p:cNvPr>
+          <p:cNvSpPr/>
+          <p:nvPr/>
+        </p:nvSpPr>
+        <p:spPr>
+          <a:xfrm>
+            <a:off x="822959" y="1463040"/>
+            <a:ext cx="7638757" cy="3200400"/>
+          </a:xfrm>
+          <a:prstGeom prst="rect">
+            <a:avLst/>
+          </a:prstGeom>
+          <a:noFill/>
+          <a:ln/>
+        </p:spPr>
+        <p:txBody>
+          <a:bodyPr wrap="square" rtlCol="0" anchor="ctr"/>
+          <a:lstStyle/>
+          <a:p>
+            <a:pPr marL="0" indent="0">
+              <a:lnSpc>
+                <a:spcPct val="130000"/>
+              </a:lnSpc>
+              <a:buNone/>
+            </a:pPr>
+            <a:r>
+              <a:rPr lang="en-US" sz="1100" dirty="0">
+                <a:solidFill>
+                  <a:srgbClr val="333333"/>
+                </a:solidFill>
+              </a:rPr>
+              <a:t>
+</a:t>
+            </a:r>
+            <a:endParaRPr lang="en-US" sz="1100" dirty="0"/>
+          </a:p>
+        </p:txBody>
+      </p:sp>
+    </p:spTree>
+    <p:extLst>
+      <p:ext uri="{BB962C8B-B14F-4D97-AF65-F5344CB8AC3E}">
+        <p14:creationId xmlns:p14="http://schemas.microsoft.com/office/powerpoint/2010/main" val="1167954537"/>
+      </p:ext>
+    </p:extLst>
+  </p:cSld>
+  <p:clrMapOvr>
+    <a:masterClrMapping/>
+  </p:clrMapOvr>
+</p:sld>
+</file>
+
+<file path=ppt/slides/slide3.xml><?xml version="1.0" encoding="utf-8"?>
+<p:sld xmlns:a="http://schemas.openxmlformats.org/drawingml/2006/main" xmlns:r="http://schemas.openxmlformats.org/officeDocument/2006/relationships" xmlns:p="http://schemas.openxmlformats.org/presentationml/2006/main">
   <p:cSld name="Slide 2">
     <p:bg>
       <p:bgPr>
@@ -6604,7 +10469,7 @@
 </p:sld>
 </file>
 
-<file path=ppt/slides/slide3.xml><?xml version="1.0" encoding="utf-8"?>
+<file path=ppt/slides/slide4.xml><?xml version="1.0" encoding="utf-8"?>
 <p:sld xmlns:a="http://schemas.openxmlformats.org/drawingml/2006/main" xmlns:r="http://schemas.openxmlformats.org/officeDocument/2006/relationships" xmlns:p="http://schemas.openxmlformats.org/presentationml/2006/main">
   <p:cSld name="Slide 3">
     <p:bg>
@@ -6644,7 +10509,9 @@
             <a:avLst/>
           </a:prstGeom>
           <a:solidFill>
-            <a:srgbClr val="4A0000"/>
+            <a:schemeClr val="accent1">
+              <a:lumMod val="50000"/>
+            </a:schemeClr>
           </a:solidFill>
           <a:ln/>
         </p:spPr>
@@ -7146,7 +11013,7 @@
 </p:sld>
 </file>
 
-<file path=ppt/slides/slide4.xml><?xml version="1.0" encoding="utf-8"?>
+<file path=ppt/slides/slide5.xml><?xml version="1.0" encoding="utf-8"?>
 <p:sld xmlns:a="http://schemas.openxmlformats.org/drawingml/2006/main" xmlns:r="http://schemas.openxmlformats.org/officeDocument/2006/relationships" xmlns:p="http://schemas.openxmlformats.org/presentationml/2006/main">
   <p:cSld name="Slide 4">
     <p:bg>
@@ -8121,7 +11988,7 @@
 </p:sld>
 </file>
 
-<file path=ppt/slides/slide5.xml><?xml version="1.0" encoding="utf-8"?>
+<file path=ppt/slides/slide6.xml><?xml version="1.0" encoding="utf-8"?>
 <p:sld xmlns:a="http://schemas.openxmlformats.org/drawingml/2006/main" xmlns:r="http://schemas.openxmlformats.org/officeDocument/2006/relationships" xmlns:p="http://schemas.openxmlformats.org/presentationml/2006/main">
   <p:cSld name="Slide 5">
     <p:bg>
@@ -8944,7 +12811,7 @@
 </p:sld>
 </file>
 
-<file path=ppt/slides/slide6.xml><?xml version="1.0" encoding="utf-8"?>
+<file path=ppt/slides/slide7.xml><?xml version="1.0" encoding="utf-8"?>
 <p:sld xmlns:a="http://schemas.openxmlformats.org/drawingml/2006/main" xmlns:r="http://schemas.openxmlformats.org/officeDocument/2006/relationships" xmlns:p="http://schemas.openxmlformats.org/presentationml/2006/main">
   <p:cSld name="Slide 6">
     <p:bg>
@@ -9986,7 +13853,7 @@
 </p:sld>
 </file>
 
-<file path=ppt/slides/slide7.xml><?xml version="1.0" encoding="utf-8"?>
+<file path=ppt/slides/slide8.xml><?xml version="1.0" encoding="utf-8"?>
 <p:sld xmlns:a="http://schemas.openxmlformats.org/drawingml/2006/main" xmlns:r="http://schemas.openxmlformats.org/officeDocument/2006/relationships" xmlns:p="http://schemas.openxmlformats.org/presentationml/2006/main">
   <p:cSld name="Slide 7">
     <p:bg>
@@ -11157,7 +15024,7 @@
 </p:sld>
 </file>
 
-<file path=ppt/slides/slide8.xml><?xml version="1.0" encoding="utf-8"?>
+<file path=ppt/slides/slide9.xml><?xml version="1.0" encoding="utf-8"?>
 <p:sld xmlns:a="http://schemas.openxmlformats.org/drawingml/2006/main" xmlns:r="http://schemas.openxmlformats.org/officeDocument/2006/relationships" xmlns:p="http://schemas.openxmlformats.org/presentationml/2006/main">
   <p:cSld name="Slide 8">
     <p:bg>
@@ -12287,869 +16154,6 @@
               <a:t>than random (0.5)</a:t>
             </a:r>
             <a:endParaRPr lang="en-US" sz="950" dirty="0"/>
-          </a:p>
-        </p:txBody>
-      </p:sp>
-    </p:spTree>
-  </p:cSld>
-  <p:clrMapOvr>
-    <a:masterClrMapping/>
-  </p:clrMapOvr>
-</p:sld>
-</file>
-
-<file path=ppt/slides/slide9.xml><?xml version="1.0" encoding="utf-8"?>
-<p:sld xmlns:a="http://schemas.openxmlformats.org/drawingml/2006/main" xmlns:r="http://schemas.openxmlformats.org/officeDocument/2006/relationships" xmlns:p="http://schemas.openxmlformats.org/presentationml/2006/main">
-  <p:cSld name="Slide 9">
-    <p:bg>
-      <p:bgPr>
-        <a:solidFill>
-          <a:srgbClr val="F0F4F8"/>
-        </a:solidFill>
-        <a:effectLst/>
-      </p:bgPr>
-    </p:bg>
-    <p:spTree>
-      <p:nvGrpSpPr>
-        <p:cNvPr id="1" name=""/>
-        <p:cNvGrpSpPr/>
-        <p:nvPr/>
-      </p:nvGrpSpPr>
-      <p:grpSpPr>
-        <a:xfrm>
-          <a:off x="0" y="0"/>
-          <a:ext cx="0" cy="0"/>
-          <a:chOff x="0" y="0"/>
-          <a:chExt cx="0" cy="0"/>
-        </a:xfrm>
-      </p:grpSpPr>
-      <p:sp>
-        <p:nvSpPr>
-          <p:cNvPr id="2" name="Shape 0"/>
-          <p:cNvSpPr/>
-          <p:nvPr/>
-        </p:nvSpPr>
-        <p:spPr>
-          <a:xfrm>
-            <a:off x="0" y="0"/>
-            <a:ext cx="9144000" cy="1005840"/>
-          </a:xfrm>
-          <a:prstGeom prst="rect">
-            <a:avLst/>
-          </a:prstGeom>
-          <a:solidFill>
-            <a:schemeClr val="accent1">
-              <a:lumMod val="50000"/>
-            </a:schemeClr>
-          </a:solidFill>
-          <a:ln/>
-        </p:spPr>
-      </p:sp>
-      <p:sp>
-        <p:nvSpPr>
-          <p:cNvPr id="3" name="Text 1"/>
-          <p:cNvSpPr/>
-          <p:nvPr/>
-        </p:nvSpPr>
-        <p:spPr>
-          <a:xfrm>
-            <a:off x="457200" y="182880"/>
-            <a:ext cx="8229600" cy="640080"/>
-          </a:xfrm>
-          <a:prstGeom prst="rect">
-            <a:avLst/>
-          </a:prstGeom>
-          <a:noFill/>
-          <a:ln/>
-        </p:spPr>
-        <p:txBody>
-          <a:bodyPr wrap="square" rtlCol="0" anchor="ctr"/>
-          <a:lstStyle/>
-          <a:p>
-            <a:pPr marL="0" indent="0">
-              <a:buNone/>
-            </a:pPr>
-            <a:r>
-              <a:rPr lang="en-US" sz="2200" b="1" dirty="0">
-                <a:solidFill>
-                  <a:srgbClr val="FFFFFF"/>
-                </a:solidFill>
-              </a:rPr>
-              <a:t>WHAT DRIVES VACCINATION?</a:t>
-            </a:r>
-            <a:endParaRPr lang="en-US" sz="2200" dirty="0"/>
-          </a:p>
-        </p:txBody>
-      </p:sp>
-      <p:sp>
-        <p:nvSpPr>
-          <p:cNvPr id="4" name="Text 2"/>
-          <p:cNvSpPr/>
-          <p:nvPr/>
-        </p:nvSpPr>
-        <p:spPr>
-          <a:xfrm>
-            <a:off x="274320" y="1051560"/>
-            <a:ext cx="8595360" cy="365760"/>
-          </a:xfrm>
-          <a:prstGeom prst="rect">
-            <a:avLst/>
-          </a:prstGeom>
-          <a:noFill/>
-          <a:ln/>
-        </p:spPr>
-        <p:txBody>
-          <a:bodyPr wrap="square" rtlCol="0" anchor="ctr"/>
-          <a:lstStyle/>
-          <a:p>
-            <a:pPr marL="0" indent="0">
-              <a:buNone/>
-            </a:pPr>
-            <a:r>
-              <a:rPr lang="en-US" sz="1200" i="1" dirty="0">
-                <a:solidFill>
-                  <a:srgbClr val="64748B"/>
-                </a:solidFill>
-              </a:rPr>
-              <a:t>Top Predictors from Random Forest Feature Importance</a:t>
-            </a:r>
-            <a:endParaRPr lang="en-US" sz="1200" dirty="0"/>
-          </a:p>
-        </p:txBody>
-      </p:sp>
-      <p:sp>
-        <p:nvSpPr>
-          <p:cNvPr id="5" name="Shape 3"/>
-          <p:cNvSpPr/>
-          <p:nvPr/>
-        </p:nvSpPr>
-        <p:spPr>
-          <a:xfrm>
-            <a:off x="2560320" y="1508760"/>
-            <a:ext cx="2139696" cy="292608"/>
-          </a:xfrm>
-          <a:prstGeom prst="rect">
-            <a:avLst/>
-          </a:prstGeom>
-          <a:solidFill>
-            <a:srgbClr val="4A0000"/>
-          </a:solidFill>
-          <a:ln/>
-        </p:spPr>
-      </p:sp>
-      <p:sp>
-        <p:nvSpPr>
-          <p:cNvPr id="6" name="Text 4"/>
-          <p:cNvSpPr/>
-          <p:nvPr/>
-        </p:nvSpPr>
-        <p:spPr>
-          <a:xfrm>
-            <a:off x="274320" y="1508760"/>
-            <a:ext cx="2240280" cy="292608"/>
-          </a:xfrm>
-          <a:prstGeom prst="rect">
-            <a:avLst/>
-          </a:prstGeom>
-          <a:noFill/>
-          <a:ln/>
-        </p:spPr>
-        <p:txBody>
-          <a:bodyPr wrap="square" lIns="0" tIns="0" rIns="0" bIns="0" rtlCol="0" anchor="ctr"/>
-          <a:lstStyle/>
-          <a:p>
-            <a:pPr marL="0" indent="0">
-              <a:buNone/>
-            </a:pPr>
-            <a:r>
-              <a:rPr lang="en-US" sz="900" b="1" dirty="0">
-                <a:solidFill>
-                  <a:srgbClr val="0F1F3D"/>
-                </a:solidFill>
-              </a:rPr>
-              <a:t>opinion_seas_risk</a:t>
-            </a:r>
-            <a:endParaRPr lang="en-US" sz="900" dirty="0"/>
-          </a:p>
-        </p:txBody>
-      </p:sp>
-      <p:sp>
-        <p:nvSpPr>
-          <p:cNvPr id="7" name="Text 5"/>
-          <p:cNvSpPr/>
-          <p:nvPr/>
-        </p:nvSpPr>
-        <p:spPr>
-          <a:xfrm>
-            <a:off x="4745736" y="1508760"/>
-            <a:ext cx="731520" cy="292608"/>
-          </a:xfrm>
-          <a:prstGeom prst="rect">
-            <a:avLst/>
-          </a:prstGeom>
-          <a:noFill/>
-          <a:ln/>
-        </p:spPr>
-        <p:txBody>
-          <a:bodyPr wrap="square" lIns="0" tIns="0" rIns="0" bIns="0" rtlCol="0" anchor="ctr"/>
-          <a:lstStyle/>
-          <a:p>
-            <a:pPr marL="0" indent="0">
-              <a:buNone/>
-            </a:pPr>
-            <a:r>
-              <a:rPr lang="en-US" sz="900" b="1" dirty="0">
-                <a:solidFill>
-                  <a:srgbClr val="4A0000"/>
-                </a:solidFill>
-              </a:rPr>
-              <a:t>r=0.39</a:t>
-            </a:r>
-            <a:endParaRPr lang="en-US" sz="900" dirty="0"/>
-          </a:p>
-        </p:txBody>
-      </p:sp>
-      <p:sp>
-        <p:nvSpPr>
-          <p:cNvPr id="8" name="Shape 6"/>
-          <p:cNvSpPr/>
-          <p:nvPr/>
-        </p:nvSpPr>
-        <p:spPr>
-          <a:xfrm>
-            <a:off x="2560320" y="1956816"/>
-            <a:ext cx="2024482" cy="292608"/>
-          </a:xfrm>
-          <a:prstGeom prst="rect">
-            <a:avLst/>
-          </a:prstGeom>
-          <a:solidFill>
-            <a:srgbClr val="0F1F3D"/>
-          </a:solidFill>
-          <a:ln/>
-        </p:spPr>
-      </p:sp>
-      <p:sp>
-        <p:nvSpPr>
-          <p:cNvPr id="9" name="Text 7"/>
-          <p:cNvSpPr/>
-          <p:nvPr/>
-        </p:nvSpPr>
-        <p:spPr>
-          <a:xfrm>
-            <a:off x="274320" y="1956816"/>
-            <a:ext cx="2240280" cy="292608"/>
-          </a:xfrm>
-          <a:prstGeom prst="rect">
-            <a:avLst/>
-          </a:prstGeom>
-          <a:noFill/>
-          <a:ln/>
-        </p:spPr>
-        <p:txBody>
-          <a:bodyPr wrap="square" lIns="0" tIns="0" rIns="0" bIns="0" rtlCol="0" anchor="ctr"/>
-          <a:lstStyle/>
-          <a:p>
-            <a:pPr marL="0" indent="0">
-              <a:buNone/>
-            </a:pPr>
-            <a:r>
-              <a:rPr lang="en-US" sz="900" b="1" dirty="0">
-                <a:solidFill>
-                  <a:srgbClr val="0F1F3D"/>
-                </a:solidFill>
-              </a:rPr>
-              <a:t>doctor_recc_seasonal</a:t>
-            </a:r>
-            <a:endParaRPr lang="en-US" sz="900" dirty="0"/>
-          </a:p>
-        </p:txBody>
-      </p:sp>
-      <p:sp>
-        <p:nvSpPr>
-          <p:cNvPr id="10" name="Text 8"/>
-          <p:cNvSpPr/>
-          <p:nvPr/>
-        </p:nvSpPr>
-        <p:spPr>
-          <a:xfrm>
-            <a:off x="4630522" y="1956816"/>
-            <a:ext cx="731520" cy="292608"/>
-          </a:xfrm>
-          <a:prstGeom prst="rect">
-            <a:avLst/>
-          </a:prstGeom>
-          <a:noFill/>
-          <a:ln/>
-        </p:spPr>
-        <p:txBody>
-          <a:bodyPr wrap="square" lIns="0" tIns="0" rIns="0" bIns="0" rtlCol="0" anchor="ctr"/>
-          <a:lstStyle/>
-          <a:p>
-            <a:pPr marL="0" indent="0">
-              <a:buNone/>
-            </a:pPr>
-            <a:r>
-              <a:rPr lang="en-US" sz="900" b="1" dirty="0">
-                <a:solidFill>
-                  <a:srgbClr val="0F1F3D"/>
-                </a:solidFill>
-              </a:rPr>
-              <a:t>r=0.369</a:t>
-            </a:r>
-            <a:endParaRPr lang="en-US" sz="900" dirty="0"/>
-          </a:p>
-        </p:txBody>
-      </p:sp>
-      <p:sp>
-        <p:nvSpPr>
-          <p:cNvPr id="11" name="Shape 9"/>
-          <p:cNvSpPr/>
-          <p:nvPr/>
-        </p:nvSpPr>
-        <p:spPr>
-          <a:xfrm>
-            <a:off x="2560320" y="2404872"/>
-            <a:ext cx="1986077" cy="292608"/>
-          </a:xfrm>
-          <a:prstGeom prst="rect">
-            <a:avLst/>
-          </a:prstGeom>
-          <a:solidFill>
-            <a:srgbClr val="8B4513"/>
-          </a:solidFill>
-          <a:ln/>
-        </p:spPr>
-      </p:sp>
-      <p:sp>
-        <p:nvSpPr>
-          <p:cNvPr id="12" name="Text 10"/>
-          <p:cNvSpPr/>
-          <p:nvPr/>
-        </p:nvSpPr>
-        <p:spPr>
-          <a:xfrm>
-            <a:off x="274320" y="2404872"/>
-            <a:ext cx="2240280" cy="292608"/>
-          </a:xfrm>
-          <a:prstGeom prst="rect">
-            <a:avLst/>
-          </a:prstGeom>
-          <a:noFill/>
-          <a:ln/>
-        </p:spPr>
-        <p:txBody>
-          <a:bodyPr wrap="square" lIns="0" tIns="0" rIns="0" bIns="0" rtlCol="0" anchor="ctr"/>
-          <a:lstStyle/>
-          <a:p>
-            <a:pPr marL="0" indent="0">
-              <a:buNone/>
-            </a:pPr>
-            <a:r>
-              <a:rPr lang="en-US" sz="900" b="1" dirty="0">
-                <a:solidFill>
-                  <a:srgbClr val="0F1F3D"/>
-                </a:solidFill>
-              </a:rPr>
-              <a:t>opinion_seas_vacc_effective</a:t>
-            </a:r>
-            <a:endParaRPr lang="en-US" sz="900" dirty="0"/>
-          </a:p>
-        </p:txBody>
-      </p:sp>
-      <p:sp>
-        <p:nvSpPr>
-          <p:cNvPr id="13" name="Text 11"/>
-          <p:cNvSpPr/>
-          <p:nvPr/>
-        </p:nvSpPr>
-        <p:spPr>
-          <a:xfrm>
-            <a:off x="4592117" y="2404872"/>
-            <a:ext cx="731520" cy="292608"/>
-          </a:xfrm>
-          <a:prstGeom prst="rect">
-            <a:avLst/>
-          </a:prstGeom>
-          <a:noFill/>
-          <a:ln/>
-        </p:spPr>
-        <p:txBody>
-          <a:bodyPr wrap="square" lIns="0" tIns="0" rIns="0" bIns="0" rtlCol="0" anchor="ctr"/>
-          <a:lstStyle/>
-          <a:p>
-            <a:pPr marL="0" indent="0">
-              <a:buNone/>
-            </a:pPr>
-            <a:r>
-              <a:rPr lang="en-US" sz="900" b="1" dirty="0">
-                <a:solidFill>
-                  <a:srgbClr val="8B4513"/>
-                </a:solidFill>
-              </a:rPr>
-              <a:t>r=0.362</a:t>
-            </a:r>
-            <a:endParaRPr lang="en-US" sz="900" dirty="0"/>
-          </a:p>
-        </p:txBody>
-      </p:sp>
-      <p:sp>
-        <p:nvSpPr>
-          <p:cNvPr id="14" name="Shape 12"/>
-          <p:cNvSpPr/>
-          <p:nvPr/>
-        </p:nvSpPr>
-        <p:spPr>
-          <a:xfrm>
-            <a:off x="2560320" y="2852928"/>
-            <a:ext cx="1102766" cy="292608"/>
-          </a:xfrm>
-          <a:prstGeom prst="rect">
-            <a:avLst/>
-          </a:prstGeom>
-          <a:solidFill>
-            <a:srgbClr val="006400"/>
-          </a:solidFill>
-          <a:ln/>
-        </p:spPr>
-      </p:sp>
-      <p:sp>
-        <p:nvSpPr>
-          <p:cNvPr id="15" name="Text 13"/>
-          <p:cNvSpPr/>
-          <p:nvPr/>
-        </p:nvSpPr>
-        <p:spPr>
-          <a:xfrm>
-            <a:off x="274320" y="2852928"/>
-            <a:ext cx="2240280" cy="292608"/>
-          </a:xfrm>
-          <a:prstGeom prst="rect">
-            <a:avLst/>
-          </a:prstGeom>
-          <a:noFill/>
-          <a:ln/>
-        </p:spPr>
-        <p:txBody>
-          <a:bodyPr wrap="square" lIns="0" tIns="0" rIns="0" bIns="0" rtlCol="0" anchor="ctr"/>
-          <a:lstStyle/>
-          <a:p>
-            <a:pPr marL="0" indent="0">
-              <a:buNone/>
-            </a:pPr>
-            <a:r>
-              <a:rPr lang="en-US" sz="900" b="1" dirty="0">
-                <a:solidFill>
-                  <a:srgbClr val="0F1F3D"/>
-                </a:solidFill>
-              </a:rPr>
-              <a:t>health_insurance</a:t>
-            </a:r>
-            <a:endParaRPr lang="en-US" sz="900" dirty="0"/>
-          </a:p>
-        </p:txBody>
-      </p:sp>
-      <p:sp>
-        <p:nvSpPr>
-          <p:cNvPr id="16" name="Text 14"/>
-          <p:cNvSpPr/>
-          <p:nvPr/>
-        </p:nvSpPr>
-        <p:spPr>
-          <a:xfrm>
-            <a:off x="3708806" y="2852928"/>
-            <a:ext cx="731520" cy="292608"/>
-          </a:xfrm>
-          <a:prstGeom prst="rect">
-            <a:avLst/>
-          </a:prstGeom>
-          <a:noFill/>
-          <a:ln/>
-        </p:spPr>
-        <p:txBody>
-          <a:bodyPr wrap="square" lIns="0" tIns="0" rIns="0" bIns="0" rtlCol="0" anchor="ctr"/>
-          <a:lstStyle/>
-          <a:p>
-            <a:pPr marL="0" indent="0">
-              <a:buNone/>
-            </a:pPr>
-            <a:r>
-              <a:rPr lang="en-US" sz="900" b="1" dirty="0">
-                <a:solidFill>
-                  <a:srgbClr val="006400"/>
-                </a:solidFill>
-              </a:rPr>
-              <a:t>r=0.201</a:t>
-            </a:r>
-            <a:endParaRPr lang="en-US" sz="900" dirty="0"/>
-          </a:p>
-        </p:txBody>
-      </p:sp>
-      <p:sp>
-        <p:nvSpPr>
-          <p:cNvPr id="17" name="Shape 15"/>
-          <p:cNvSpPr/>
-          <p:nvPr/>
-        </p:nvSpPr>
-        <p:spPr>
-          <a:xfrm>
-            <a:off x="2560320" y="3300984"/>
-            <a:ext cx="932688" cy="292608"/>
-          </a:xfrm>
-          <a:prstGeom prst="rect">
-            <a:avLst/>
-          </a:prstGeom>
-          <a:solidFill>
-            <a:srgbClr val="4B0082"/>
-          </a:solidFill>
-          <a:ln/>
-        </p:spPr>
-      </p:sp>
-      <p:sp>
-        <p:nvSpPr>
-          <p:cNvPr id="18" name="Text 16"/>
-          <p:cNvSpPr/>
-          <p:nvPr/>
-        </p:nvSpPr>
-        <p:spPr>
-          <a:xfrm>
-            <a:off x="274320" y="3300984"/>
-            <a:ext cx="2240280" cy="292608"/>
-          </a:xfrm>
-          <a:prstGeom prst="rect">
-            <a:avLst/>
-          </a:prstGeom>
-          <a:noFill/>
-          <a:ln/>
-        </p:spPr>
-        <p:txBody>
-          <a:bodyPr wrap="square" lIns="0" tIns="0" rIns="0" bIns="0" rtlCol="0" anchor="ctr"/>
-          <a:lstStyle/>
-          <a:p>
-            <a:pPr marL="0" indent="0">
-              <a:buNone/>
-            </a:pPr>
-            <a:r>
-              <a:rPr lang="en-US" sz="900" b="1" dirty="0">
-                <a:solidFill>
-                  <a:srgbClr val="0F1F3D"/>
-                </a:solidFill>
-              </a:rPr>
-              <a:t>chronic_med_condition</a:t>
-            </a:r>
-            <a:endParaRPr lang="en-US" sz="900" dirty="0"/>
-          </a:p>
-        </p:txBody>
-      </p:sp>
-      <p:sp>
-        <p:nvSpPr>
-          <p:cNvPr id="19" name="Text 17"/>
-          <p:cNvSpPr/>
-          <p:nvPr/>
-        </p:nvSpPr>
-        <p:spPr>
-          <a:xfrm>
-            <a:off x="3538728" y="3300984"/>
-            <a:ext cx="731520" cy="292608"/>
-          </a:xfrm>
-          <a:prstGeom prst="rect">
-            <a:avLst/>
-          </a:prstGeom>
-          <a:noFill/>
-          <a:ln/>
-        </p:spPr>
-        <p:txBody>
-          <a:bodyPr wrap="square" lIns="0" tIns="0" rIns="0" bIns="0" rtlCol="0" anchor="ctr"/>
-          <a:lstStyle/>
-          <a:p>
-            <a:pPr marL="0" indent="0">
-              <a:buNone/>
-            </a:pPr>
-            <a:r>
-              <a:rPr lang="en-US" sz="900" b="1" dirty="0">
-                <a:solidFill>
-                  <a:srgbClr val="4B0082"/>
-                </a:solidFill>
-              </a:rPr>
-              <a:t>r=0.17</a:t>
-            </a:r>
-            <a:endParaRPr lang="en-US" sz="900" dirty="0"/>
-          </a:p>
-        </p:txBody>
-      </p:sp>
-      <p:sp>
-        <p:nvSpPr>
-          <p:cNvPr id="20" name="Shape 18"/>
-          <p:cNvSpPr/>
-          <p:nvPr/>
-        </p:nvSpPr>
-        <p:spPr>
-          <a:xfrm>
-            <a:off x="2560320" y="3749040"/>
-            <a:ext cx="696773" cy="292608"/>
-          </a:xfrm>
-          <a:prstGeom prst="rect">
-            <a:avLst/>
-          </a:prstGeom>
-          <a:solidFill>
-            <a:srgbClr val="8B0000"/>
-          </a:solidFill>
-          <a:ln/>
-        </p:spPr>
-      </p:sp>
-      <p:sp>
-        <p:nvSpPr>
-          <p:cNvPr id="21" name="Text 19"/>
-          <p:cNvSpPr/>
-          <p:nvPr/>
-        </p:nvSpPr>
-        <p:spPr>
-          <a:xfrm>
-            <a:off x="274320" y="3749040"/>
-            <a:ext cx="2240280" cy="292608"/>
-          </a:xfrm>
-          <a:prstGeom prst="rect">
-            <a:avLst/>
-          </a:prstGeom>
-          <a:noFill/>
-          <a:ln/>
-        </p:spPr>
-        <p:txBody>
-          <a:bodyPr wrap="square" lIns="0" tIns="0" rIns="0" bIns="0" rtlCol="0" anchor="ctr"/>
-          <a:lstStyle/>
-          <a:p>
-            <a:pPr marL="0" indent="0">
-              <a:buNone/>
-            </a:pPr>
-            <a:r>
-              <a:rPr lang="en-US" sz="900" b="1" dirty="0">
-                <a:solidFill>
-                  <a:srgbClr val="0F1F3D"/>
-                </a:solidFill>
-              </a:rPr>
-              <a:t>health_worker</a:t>
-            </a:r>
-            <a:endParaRPr lang="en-US" sz="900" dirty="0"/>
-          </a:p>
-        </p:txBody>
-      </p:sp>
-      <p:sp>
-        <p:nvSpPr>
-          <p:cNvPr id="22" name="Text 20"/>
-          <p:cNvSpPr/>
-          <p:nvPr/>
-        </p:nvSpPr>
-        <p:spPr>
-          <a:xfrm>
-            <a:off x="3302813" y="3749040"/>
-            <a:ext cx="731520" cy="292608"/>
-          </a:xfrm>
-          <a:prstGeom prst="rect">
-            <a:avLst/>
-          </a:prstGeom>
-          <a:noFill/>
-          <a:ln/>
-        </p:spPr>
-        <p:txBody>
-          <a:bodyPr wrap="square" lIns="0" tIns="0" rIns="0" bIns="0" rtlCol="0" anchor="ctr"/>
-          <a:lstStyle/>
-          <a:p>
-            <a:pPr marL="0" indent="0">
-              <a:buNone/>
-            </a:pPr>
-            <a:r>
-              <a:rPr lang="en-US" sz="900" b="1" dirty="0">
-                <a:solidFill>
-                  <a:srgbClr val="8B0000"/>
-                </a:solidFill>
-              </a:rPr>
-              <a:t>r=0.127</a:t>
-            </a:r>
-            <a:endParaRPr lang="en-US" sz="900" dirty="0"/>
-          </a:p>
-        </p:txBody>
-      </p:sp>
-      <p:sp>
-        <p:nvSpPr>
-          <p:cNvPr id="23" name="Shape 21"/>
-          <p:cNvSpPr/>
-          <p:nvPr/>
-        </p:nvSpPr>
-        <p:spPr>
-          <a:xfrm>
-            <a:off x="2560320" y="4197096"/>
-            <a:ext cx="658368" cy="292608"/>
-          </a:xfrm>
-          <a:prstGeom prst="rect">
-            <a:avLst/>
-          </a:prstGeom>
-          <a:solidFill>
-            <a:srgbClr val="4A0000"/>
-          </a:solidFill>
-          <a:ln/>
-        </p:spPr>
-      </p:sp>
-      <p:sp>
-        <p:nvSpPr>
-          <p:cNvPr id="24" name="Text 22"/>
-          <p:cNvSpPr/>
-          <p:nvPr/>
-        </p:nvSpPr>
-        <p:spPr>
-          <a:xfrm>
-            <a:off x="274320" y="4197096"/>
-            <a:ext cx="2240280" cy="292608"/>
-          </a:xfrm>
-          <a:prstGeom prst="rect">
-            <a:avLst/>
-          </a:prstGeom>
-          <a:noFill/>
-          <a:ln/>
-        </p:spPr>
-        <p:txBody>
-          <a:bodyPr wrap="square" lIns="0" tIns="0" rIns="0" bIns="0" rtlCol="0" anchor="ctr"/>
-          <a:lstStyle/>
-          <a:p>
-            <a:pPr marL="0" indent="0">
-              <a:buNone/>
-            </a:pPr>
-            <a:r>
-              <a:rPr lang="en-US" sz="900" b="1" dirty="0">
-                <a:solidFill>
-                  <a:srgbClr val="0F1F3D"/>
-                </a:solidFill>
-              </a:rPr>
-              <a:t>behavioral_touch_face</a:t>
-            </a:r>
-            <a:endParaRPr lang="en-US" sz="900" dirty="0"/>
-          </a:p>
-        </p:txBody>
-      </p:sp>
-      <p:sp>
-        <p:nvSpPr>
-          <p:cNvPr id="25" name="Text 23"/>
-          <p:cNvSpPr/>
-          <p:nvPr/>
-        </p:nvSpPr>
-        <p:spPr>
-          <a:xfrm>
-            <a:off x="3264408" y="4197096"/>
-            <a:ext cx="731520" cy="292608"/>
-          </a:xfrm>
-          <a:prstGeom prst="rect">
-            <a:avLst/>
-          </a:prstGeom>
-          <a:noFill/>
-          <a:ln/>
-        </p:spPr>
-        <p:txBody>
-          <a:bodyPr wrap="square" lIns="0" tIns="0" rIns="0" bIns="0" rtlCol="0" anchor="ctr"/>
-          <a:lstStyle/>
-          <a:p>
-            <a:pPr marL="0" indent="0">
-              <a:buNone/>
-            </a:pPr>
-            <a:r>
-              <a:rPr lang="en-US" sz="900" b="1" dirty="0">
-                <a:solidFill>
-                  <a:srgbClr val="4A0000"/>
-                </a:solidFill>
-              </a:rPr>
-              <a:t>r=0.12</a:t>
-            </a:r>
-            <a:endParaRPr lang="en-US" sz="900" dirty="0"/>
-          </a:p>
-        </p:txBody>
-      </p:sp>
-      <p:sp>
-        <p:nvSpPr>
-          <p:cNvPr id="26" name="Shape 24"/>
-          <p:cNvSpPr/>
-          <p:nvPr/>
-        </p:nvSpPr>
-        <p:spPr>
-          <a:xfrm>
-            <a:off x="2560320" y="4645152"/>
-            <a:ext cx="614477" cy="292608"/>
-          </a:xfrm>
-          <a:prstGeom prst="rect">
-            <a:avLst/>
-          </a:prstGeom>
-          <a:solidFill>
-            <a:srgbClr val="0F1F3D"/>
-          </a:solidFill>
-          <a:ln/>
-        </p:spPr>
-      </p:sp>
-      <p:sp>
-        <p:nvSpPr>
-          <p:cNvPr id="27" name="Text 25"/>
-          <p:cNvSpPr/>
-          <p:nvPr/>
-        </p:nvSpPr>
-        <p:spPr>
-          <a:xfrm>
-            <a:off x="274320" y="4645152"/>
-            <a:ext cx="2240280" cy="292608"/>
-          </a:xfrm>
-          <a:prstGeom prst="rect">
-            <a:avLst/>
-          </a:prstGeom>
-          <a:noFill/>
-          <a:ln/>
-        </p:spPr>
-        <p:txBody>
-          <a:bodyPr wrap="square" lIns="0" tIns="0" rIns="0" bIns="0" rtlCol="0" anchor="ctr"/>
-          <a:lstStyle/>
-          <a:p>
-            <a:pPr marL="0" indent="0">
-              <a:buNone/>
-            </a:pPr>
-            <a:r>
-              <a:rPr lang="en-US" sz="900" b="1" dirty="0">
-                <a:solidFill>
-                  <a:srgbClr val="0F1F3D"/>
-                </a:solidFill>
-              </a:rPr>
-              <a:t>behavioral_wash_hands</a:t>
-            </a:r>
-            <a:endParaRPr lang="en-US" sz="900" dirty="0"/>
-          </a:p>
-        </p:txBody>
-      </p:sp>
-      <p:sp>
-        <p:nvSpPr>
-          <p:cNvPr id="28" name="Text 26"/>
-          <p:cNvSpPr/>
-          <p:nvPr/>
-        </p:nvSpPr>
-        <p:spPr>
-          <a:xfrm>
-            <a:off x="3220517" y="4645152"/>
-            <a:ext cx="731520" cy="292608"/>
-          </a:xfrm>
-          <a:prstGeom prst="rect">
-            <a:avLst/>
-          </a:prstGeom>
-          <a:noFill/>
-          <a:ln/>
-        </p:spPr>
-        <p:txBody>
-          <a:bodyPr wrap="square" lIns="0" tIns="0" rIns="0" bIns="0" rtlCol="0" anchor="ctr"/>
-          <a:lstStyle/>
-          <a:p>
-            <a:pPr marL="0" indent="0">
-              <a:buNone/>
-            </a:pPr>
-            <a:r>
-              <a:rPr lang="en-US" sz="900" b="1" dirty="0">
-                <a:solidFill>
-                  <a:srgbClr val="0F1F3D"/>
-                </a:solidFill>
-              </a:rPr>
-              <a:t>r=0.112</a:t>
-            </a:r>
-            <a:endParaRPr lang="en-US" sz="900" dirty="0"/>
           </a:p>
         </p:txBody>
       </p:sp>

</xml_diff>